<commit_message>
updated power point file
</commit_message>
<xml_diff>
--- a/reports/call_me_maybe_presentation.pptx
+++ b/reports/call_me_maybe_presentation.pptx
@@ -4,6 +4,9 @@
   <p:sldMasterIdLst>
     <p:sldMasterId id="2147483648" r:id="rId1"/>
   </p:sldMasterIdLst>
+  <p:notesMasterIdLst>
+    <p:notesMasterId r:id="rId11"/>
+  </p:notesMasterIdLst>
   <p:sldIdLst>
     <p:sldId id="256" r:id="rId2"/>
     <p:sldId id="257" r:id="rId3"/>
@@ -15,10 +18,7 @@
     <p:sldId id="263" r:id="rId9"/>
     <p:sldId id="264" r:id="rId10"/>
   </p:sldIdLst>
-  <p:notesMasterIdLst>
-    <p:notesMasterId r:id="rId11"/>
-  </p:notesMasterIdLst>
-  <p:sldSz cx="9144000" cy="5143500"/>
+  <p:sldSz cx="9144000" cy="5143500" type="screen16x9"/>
   <p:notesSz cx="5143500" cy="9144000"/>
   <p:defaultTextStyle>
     <a:lvl1pPr marL="0" algn="l" defTabSz="914400" rtl="0" eaLnBrk="1" latinLnBrk="0" hangingPunct="1">
@@ -112,6 +112,11 @@
       </a:defRPr>
     </a:lvl9pPr>
   </p:defaultTextStyle>
+  <p:extLst>
+    <p:ext uri="{EFAFB233-063F-42B5-8137-9DF3F51BA10A}">
+      <p15:sldGuideLst xmlns:p15="http://schemas.microsoft.com/office/powerpoint/2012/main"/>
+    </p:ext>
+  </p:extLst>
 </p:presentation>
 </file>
 
@@ -137,234 +142,10 @@
           <a:chExt cx="0" cy="0"/>
         </a:xfrm>
       </p:grpSpPr>
-      <p:sp>
-        <p:nvSpPr>
-          <p:cNvPr id="2" name="Header Placeholder 1"/>
-          <p:cNvSpPr>
-            <a:spLocks noGrp="1"/>
-          </p:cNvSpPr>
-          <p:nvPr>
-            <p:ph type="hdr" sz="quarter"/>
-          </p:nvPr>
-        </p:nvSpPr>
-        <p:spPr>
-          <a:xfrm>
-            <a:off x="0" y="0"/>
-            <a:ext cx="2971800" cy="458788"/>
-          </a:xfrm>
-          <a:prstGeom prst="rect">
-            <a:avLst/>
-          </a:prstGeom>
-        </p:spPr>
-        <p:txBody>
-          <a:bodyPr vert="horz" lIns="91440" tIns="45720" rIns="91440" bIns="45720" rtlCol="0"/>
-          <a:lstStyle>
-            <a:lvl1pPr algn="l">
-              <a:defRPr sz="1200"/>
-            </a:lvl1pPr>
-          </a:lstStyle>
-          <a:p>
-            <a:endParaRPr lang="en-US"/>
-          </a:p>
-        </p:txBody>
-      </p:sp>
-      <p:sp>
-        <p:nvSpPr>
-          <p:cNvPr id="3" name="Date Placeholder 2"/>
-          <p:cNvSpPr>
-            <a:spLocks noGrp="1"/>
-          </p:cNvSpPr>
-          <p:nvPr>
-            <p:ph type="dt" idx="1"/>
-          </p:nvPr>
-        </p:nvSpPr>
-        <p:spPr>
-          <a:xfrm>
-            <a:off x="3884613" y="0"/>
-            <a:ext cx="2971800" cy="458788"/>
-          </a:xfrm>
-          <a:prstGeom prst="rect">
-            <a:avLst/>
-          </a:prstGeom>
-        </p:spPr>
-        <p:txBody>
-          <a:bodyPr vert="horz" lIns="91440" tIns="45720" rIns="91440" bIns="45720" rtlCol="0"/>
-          <a:lstStyle>
-            <a:lvl1pPr algn="r">
-              <a:defRPr sz="1200"/>
-            </a:lvl1pPr>
-          </a:lstStyle>
-          <a:p>
-            <a:fld id="{5282F153-3F37-0F45-9E97-73ACFA13230C}" type="datetimeFigureOut">
-              <a:rPr lang="en-US"/>
-              <a:t>7/23/19</a:t>
-            </a:fld>
-            <a:endParaRPr lang="en-US"/>
-          </a:p>
-        </p:txBody>
-      </p:sp>
-      <p:sp>
-        <p:nvSpPr>
-          <p:cNvPr id="4" name="Slide Image Placeholder 3"/>
-          <p:cNvSpPr>
-            <a:spLocks noGrp="1" noRot="1" noChangeAspect="1"/>
-          </p:cNvSpPr>
-          <p:nvPr>
-            <p:ph type="sldImg" idx="2"/>
-          </p:nvPr>
-        </p:nvSpPr>
-        <p:spPr>
-          <a:xfrm>
-            <a:off x="685800" y="1143000"/>
-            <a:ext cx="5486400" cy="3086100"/>
-          </a:xfrm>
-          <a:prstGeom prst="rect">
-            <a:avLst/>
-          </a:prstGeom>
-          <a:noFill/>
-          <a:ln w="12700">
-            <a:solidFill>
-              <a:prstClr val="black"/>
-            </a:solidFill>
-          </a:ln>
-        </p:spPr>
-        <p:txBody>
-          <a:bodyPr vert="horz" lIns="91440" tIns="45720" rIns="91440" bIns="45720" rtlCol="0" anchor="ctr"/>
-          <a:lstStyle/>
-          <a:p>
-            <a:endParaRPr lang="en-US"/>
-          </a:p>
-        </p:txBody>
-      </p:sp>
-      <p:sp>
-        <p:nvSpPr>
-          <p:cNvPr id="5" name="Notes Placeholder 4"/>
-          <p:cNvSpPr>
-            <a:spLocks noGrp="1"/>
-          </p:cNvSpPr>
-          <p:nvPr>
-            <p:ph type="body" sz="quarter" idx="3"/>
-          </p:nvPr>
-        </p:nvSpPr>
-        <p:spPr>
-          <a:xfrm>
-            <a:off x="685800" y="4400550"/>
-            <a:ext cx="5486400" cy="3600450"/>
-          </a:xfrm>
-          <a:prstGeom prst="rect">
-            <a:avLst/>
-          </a:prstGeom>
-        </p:spPr>
-        <p:txBody>
-          <a:bodyPr vert="horz" lIns="91440" tIns="45720" rIns="91440" bIns="45720" rtlCol="0"/>
-          <a:lstStyle/>
-          <a:p>
-            <a:pPr lvl="0"/>
-            <a:r>
-              <a:rPr lang="en-US"/>
-              <a:t>Click to edit Master text styles</a:t>
-            </a:r>
-          </a:p>
-          <a:p>
-            <a:pPr lvl="1"/>
-            <a:r>
-              <a:rPr lang="en-US"/>
-              <a:t>Second level</a:t>
-            </a:r>
-          </a:p>
-          <a:p>
-            <a:pPr lvl="2"/>
-            <a:r>
-              <a:rPr lang="en-US"/>
-              <a:t>Third level</a:t>
-            </a:r>
-          </a:p>
-          <a:p>
-            <a:pPr lvl="3"/>
-            <a:r>
-              <a:rPr lang="en-US"/>
-              <a:t>Fourth level</a:t>
-            </a:r>
-          </a:p>
-          <a:p>
-            <a:pPr lvl="4"/>
-            <a:r>
-              <a:rPr lang="en-US"/>
-              <a:t>Fifth level</a:t>
-            </a:r>
-          </a:p>
-        </p:txBody>
-      </p:sp>
-      <p:sp>
-        <p:nvSpPr>
-          <p:cNvPr id="6" name="Footer Placeholder 5"/>
-          <p:cNvSpPr>
-            <a:spLocks noGrp="1"/>
-          </p:cNvSpPr>
-          <p:nvPr>
-            <p:ph type="ftr" sz="quarter" idx="4"/>
-          </p:nvPr>
-        </p:nvSpPr>
-        <p:spPr>
-          <a:xfrm>
-            <a:off x="0" y="8685213"/>
-            <a:ext cx="2971800" cy="458787"/>
-          </a:xfrm>
-          <a:prstGeom prst="rect">
-            <a:avLst/>
-          </a:prstGeom>
-        </p:spPr>
-        <p:txBody>
-          <a:bodyPr vert="horz" lIns="91440" tIns="45720" rIns="91440" bIns="45720" rtlCol="0" anchor="b"/>
-          <a:lstStyle>
-            <a:lvl1pPr algn="l">
-              <a:defRPr sz="1200"/>
-            </a:lvl1pPr>
-          </a:lstStyle>
-          <a:p>
-            <a:endParaRPr lang="en-US"/>
-          </a:p>
-        </p:txBody>
-      </p:sp>
-      <p:sp>
-        <p:nvSpPr>
-          <p:cNvPr id="7" name="Slide Number Placeholder 6"/>
-          <p:cNvSpPr>
-            <a:spLocks noGrp="1"/>
-          </p:cNvSpPr>
-          <p:nvPr>
-            <p:ph type="sldNum" sz="quarter" idx="5"/>
-          </p:nvPr>
-        </p:nvSpPr>
-        <p:spPr>
-          <a:xfrm>
-            <a:off x="3884613" y="8685213"/>
-            <a:ext cx="2971800" cy="458787"/>
-          </a:xfrm>
-          <a:prstGeom prst="rect">
-            <a:avLst/>
-          </a:prstGeom>
-        </p:spPr>
-        <p:txBody>
-          <a:bodyPr vert="horz" lIns="91440" tIns="45720" rIns="91440" bIns="45720" rtlCol="0" anchor="b"/>
-          <a:lstStyle>
-            <a:lvl1pPr algn="r">
-              <a:defRPr sz="1200"/>
-            </a:lvl1pPr>
-          </a:lstStyle>
-          <a:p>
-            <a:fld id="{CE5E9CC1-C706-0F49-92D6-E571CC5EEA8F}" type="slidenum">
-              <a:rPr lang="en-US"/>
-              <a:t>‹#›</a:t>
-            </a:fld>
-            <a:endParaRPr lang="en-US"/>
-          </a:p>
-        </p:txBody>
-      </p:sp>
     </p:spTree>
     <p:extLst>
       <p:ext uri="{BB962C8B-B14F-4D97-AF65-F5344CB8AC3E}">
-        <p14:creationId xmlns:p14="http://schemas.microsoft.com/office/powerpoint/2010/main" val="1024086991"/>
+        <p14:creationId xmlns:p14="http://schemas.microsoft.com/office/powerpoint/2010/main" val="2404203962"/>
       </p:ext>
     </p:extLst>
   </p:cSld>
@@ -508,10 +289,6 @@
           <a:bodyPr/>
           <a:lstStyle/>
           <a:p>
-            <a:r>
-              <a:rPr lang="en-US" dirty="0"/>
-              <a:t/>
-            </a:r>
             <a:endParaRPr lang="en-US" dirty="0"/>
           </a:p>
         </p:txBody>
@@ -596,10 +373,6 @@
           <a:bodyPr/>
           <a:lstStyle/>
           <a:p>
-            <a:r>
-              <a:rPr lang="en-US" dirty="0"/>
-              <a:t/>
-            </a:r>
             <a:endParaRPr lang="en-US" dirty="0"/>
           </a:p>
         </p:txBody>
@@ -684,10 +457,6 @@
           <a:bodyPr/>
           <a:lstStyle/>
           <a:p>
-            <a:r>
-              <a:rPr lang="en-US" dirty="0"/>
-              <a:t/>
-            </a:r>
             <a:endParaRPr lang="en-US" dirty="0"/>
           </a:p>
         </p:txBody>
@@ -772,10 +541,6 @@
           <a:bodyPr/>
           <a:lstStyle/>
           <a:p>
-            <a:r>
-              <a:rPr lang="en-US" dirty="0"/>
-              <a:t/>
-            </a:r>
             <a:endParaRPr lang="en-US" dirty="0"/>
           </a:p>
         </p:txBody>
@@ -860,10 +625,6 @@
           <a:bodyPr/>
           <a:lstStyle/>
           <a:p>
-            <a:r>
-              <a:rPr lang="en-US" dirty="0"/>
-              <a:t/>
-            </a:r>
             <a:endParaRPr lang="en-US" dirty="0"/>
           </a:p>
         </p:txBody>
@@ -948,10 +709,6 @@
           <a:bodyPr/>
           <a:lstStyle/>
           <a:p>
-            <a:r>
-              <a:rPr lang="en-US" dirty="0"/>
-              <a:t/>
-            </a:r>
             <a:endParaRPr lang="en-US" dirty="0"/>
           </a:p>
         </p:txBody>
@@ -1036,10 +793,6 @@
           <a:bodyPr/>
           <a:lstStyle/>
           <a:p>
-            <a:r>
-              <a:rPr lang="en-US" dirty="0"/>
-              <a:t/>
-            </a:r>
             <a:endParaRPr lang="en-US" dirty="0"/>
           </a:p>
         </p:txBody>
@@ -1124,10 +877,6 @@
           <a:bodyPr/>
           <a:lstStyle/>
           <a:p>
-            <a:r>
-              <a:rPr lang="en-US" dirty="0"/>
-              <a:t/>
-            </a:r>
             <a:endParaRPr lang="en-US" dirty="0"/>
           </a:p>
         </p:txBody>
@@ -1212,10 +961,6 @@
           <a:bodyPr/>
           <a:lstStyle/>
           <a:p>
-            <a:r>
-              <a:rPr lang="en-US" dirty="0"/>
-              <a:t/>
-            </a:r>
             <a:endParaRPr lang="en-US" dirty="0"/>
           </a:p>
         </p:txBody>
@@ -1289,6 +1034,11 @@
 <file path=ppt/slideMasters/slideMaster1.xml><?xml version="1.0" encoding="utf-8"?>
 <p:sldMaster xmlns:a="http://schemas.openxmlformats.org/drawingml/2006/main" xmlns:r="http://schemas.openxmlformats.org/officeDocument/2006/relationships" xmlns:p="http://schemas.openxmlformats.org/presentationml/2006/main">
   <p:cSld>
+    <p:bg>
+      <p:bgRef idx="1001">
+        <a:schemeClr val="bg1"/>
+      </p:bgRef>
+    </p:bg>
     <p:spTree>
       <p:nvGrpSpPr>
         <p:cNvPr id="1" name=""/>
@@ -1599,6 +1349,13 @@
           </a:solidFill>
           <a:ln/>
         </p:spPr>
+        <p:txBody>
+          <a:bodyPr/>
+          <a:lstStyle/>
+          <a:p>
+            <a:endParaRPr lang="en-US"/>
+          </a:p>
+        </p:txBody>
       </p:sp>
       <p:sp>
         <p:nvSpPr>
@@ -1619,6 +1376,13 @@
           </a:solidFill>
           <a:ln/>
         </p:spPr>
+        <p:txBody>
+          <a:bodyPr/>
+          <a:lstStyle/>
+          <a:p>
+            <a:endParaRPr lang="en-US"/>
+          </a:p>
+        </p:txBody>
       </p:sp>
       <p:sp>
         <p:nvSpPr>
@@ -1639,6 +1403,13 @@
           </a:solidFill>
           <a:ln/>
         </p:spPr>
+        <p:txBody>
+          <a:bodyPr/>
+          <a:lstStyle/>
+          <a:p>
+            <a:endParaRPr lang="en-US"/>
+          </a:p>
+        </p:txBody>
       </p:sp>
       <p:sp>
         <p:nvSpPr>
@@ -1661,11 +1432,11 @@
           <a:bodyPr wrap="square" rtlCol="0" anchor="ctr"/>
           <a:lstStyle/>
           <a:p>
-            <a:pPr indent="0" marL="0">
-              <a:buNone/>
-            </a:pPr>
-            <a:r>
-              <a:rPr lang="en-US" sz="900" b="1" spc="300" kern="0" dirty="0">
+            <a:pPr marL="0" indent="0">
+              <a:buNone/>
+            </a:pPr>
+            <a:r>
+              <a:rPr lang="en-US" sz="900" b="1" kern="0" spc="300" dirty="0">
                 <a:solidFill>
                   <a:srgbClr val="F4A261"/>
                 </a:solidFill>
@@ -1700,7 +1471,7 @@
           <a:bodyPr wrap="square" rtlCol="0" anchor="ctr"/>
           <a:lstStyle/>
           <a:p>
-            <a:pPr indent="0" marL="0">
+            <a:pPr marL="0" indent="0">
               <a:buNone/>
             </a:pPr>
             <a:r>
@@ -1739,7 +1510,7 @@
           <a:bodyPr wrap="square" rtlCol="0" anchor="ctr"/>
           <a:lstStyle/>
           <a:p>
-            <a:pPr indent="0" marL="0">
+            <a:pPr marL="0" indent="0">
               <a:buNone/>
             </a:pPr>
             <a:r>
@@ -1756,7 +1527,7 @@
             <a:endParaRPr lang="en-US" sz="1600" dirty="0"/>
           </a:p>
           <a:p>
-            <a:pPr indent="0" marL="0">
+            <a:pPr marL="0" indent="0">
               <a:buNone/>
             </a:pPr>
             <a:r>
@@ -1793,6 +1564,13 @@
           </a:solidFill>
           <a:ln/>
         </p:spPr>
+        <p:txBody>
+          <a:bodyPr/>
+          <a:lstStyle/>
+          <a:p>
+            <a:endParaRPr lang="en-US"/>
+          </a:p>
+        </p:txBody>
       </p:sp>
       <p:sp>
         <p:nvSpPr>
@@ -1815,6 +1593,13 @@
           </a:solidFill>
           <a:ln/>
         </p:spPr>
+        <p:txBody>
+          <a:bodyPr/>
+          <a:lstStyle/>
+          <a:p>
+            <a:endParaRPr lang="en-US"/>
+          </a:p>
+        </p:txBody>
       </p:sp>
       <p:sp>
         <p:nvSpPr>
@@ -1837,7 +1622,7 @@
           <a:bodyPr wrap="square" lIns="0" tIns="0" rIns="0" bIns="0" rtlCol="0" anchor="ctr"/>
           <a:lstStyle/>
           <a:p>
-            <a:pPr algn="ctr" indent="0" marL="0">
+            <a:pPr marL="0" indent="0" algn="ctr">
               <a:buNone/>
             </a:pPr>
             <a:r>
@@ -1876,6 +1661,13 @@
           </a:solidFill>
           <a:ln/>
         </p:spPr>
+        <p:txBody>
+          <a:bodyPr/>
+          <a:lstStyle/>
+          <a:p>
+            <a:endParaRPr lang="en-US"/>
+          </a:p>
+        </p:txBody>
       </p:sp>
       <p:sp>
         <p:nvSpPr>
@@ -1898,7 +1690,7 @@
           <a:bodyPr wrap="square" lIns="0" tIns="0" rIns="0" bIns="0" rtlCol="0" anchor="ctr"/>
           <a:lstStyle/>
           <a:p>
-            <a:pPr algn="ctr" indent="0" marL="0">
+            <a:pPr marL="0" indent="0" algn="ctr">
               <a:buNone/>
             </a:pPr>
             <a:r>
@@ -1937,6 +1729,13 @@
           </a:solidFill>
           <a:ln/>
         </p:spPr>
+        <p:txBody>
+          <a:bodyPr/>
+          <a:lstStyle/>
+          <a:p>
+            <a:endParaRPr lang="en-US"/>
+          </a:p>
+        </p:txBody>
       </p:sp>
       <p:sp>
         <p:nvSpPr>
@@ -1959,7 +1758,7 @@
           <a:bodyPr wrap="square" lIns="0" tIns="0" rIns="0" bIns="0" rtlCol="0" anchor="ctr"/>
           <a:lstStyle/>
           <a:p>
-            <a:pPr algn="ctr" indent="0" marL="0">
+            <a:pPr marL="0" indent="0" algn="ctr">
               <a:buNone/>
             </a:pPr>
             <a:r>
@@ -1998,6 +1797,13 @@
           </a:solidFill>
           <a:ln/>
         </p:spPr>
+        <p:txBody>
+          <a:bodyPr/>
+          <a:lstStyle/>
+          <a:p>
+            <a:endParaRPr lang="en-US"/>
+          </a:p>
+        </p:txBody>
       </p:sp>
       <p:sp>
         <p:nvSpPr>
@@ -2020,7 +1826,7 @@
           <a:bodyPr wrap="square" lIns="0" tIns="0" rIns="0" bIns="0" rtlCol="0" anchor="ctr"/>
           <a:lstStyle/>
           <a:p>
-            <a:pPr algn="ctr" indent="0" marL="0">
+            <a:pPr marL="0" indent="0" algn="ctr">
               <a:buNone/>
             </a:pPr>
             <a:r>
@@ -2059,7 +1865,7 @@
           <a:bodyPr wrap="square" rtlCol="0" anchor="ctr"/>
           <a:lstStyle/>
           <a:p>
-            <a:pPr indent="0" marL="0">
+            <a:pPr marL="0" indent="0">
               <a:buNone/>
             </a:pPr>
             <a:r>
@@ -2121,6 +1927,13 @@
           </a:solidFill>
           <a:ln/>
         </p:spPr>
+        <p:txBody>
+          <a:bodyPr/>
+          <a:lstStyle/>
+          <a:p>
+            <a:endParaRPr lang="en-US"/>
+          </a:p>
+        </p:txBody>
       </p:sp>
       <p:sp>
         <p:nvSpPr>
@@ -2141,6 +1954,13 @@
           </a:solidFill>
           <a:ln/>
         </p:spPr>
+        <p:txBody>
+          <a:bodyPr/>
+          <a:lstStyle/>
+          <a:p>
+            <a:endParaRPr lang="en-US"/>
+          </a:p>
+        </p:txBody>
       </p:sp>
       <p:sp>
         <p:nvSpPr>
@@ -2163,11 +1983,11 @@
           <a:bodyPr wrap="square" rtlCol="0" anchor="ctr"/>
           <a:lstStyle/>
           <a:p>
-            <a:pPr indent="0" marL="0">
-              <a:buNone/>
-            </a:pPr>
-            <a:r>
-              <a:rPr lang="en-US" sz="800" b="1" spc="300" kern="0" dirty="0">
+            <a:pPr marL="0" indent="0">
+              <a:buNone/>
+            </a:pPr>
+            <a:r>
+              <a:rPr lang="en-US" sz="800" b="1" kern="0" spc="300" dirty="0">
                 <a:solidFill>
                   <a:srgbClr val="F4A261"/>
                 </a:solidFill>
@@ -2202,7 +2022,7 @@
           <a:bodyPr wrap="square" rtlCol="0" anchor="ctr"/>
           <a:lstStyle/>
           <a:p>
-            <a:pPr indent="0" marL="0">
+            <a:pPr marL="0" indent="0">
               <a:buNone/>
             </a:pPr>
             <a:r>
@@ -2219,7 +2039,7 @@
             <a:endParaRPr lang="en-US" sz="3600" dirty="0"/>
           </a:p>
           <a:p>
-            <a:pPr indent="0" marL="0">
+            <a:pPr marL="0" indent="0">
               <a:buNone/>
             </a:pPr>
             <a:r>
@@ -2258,7 +2078,7 @@
           <a:bodyPr wrap="square" rtlCol="0" anchor="ctr"/>
           <a:lstStyle/>
           <a:p>
-            <a:pPr indent="0" marL="0">
+            <a:pPr marL="0" indent="0">
               <a:buNone/>
             </a:pPr>
             <a:r>
@@ -2275,13 +2095,13 @@
             <a:endParaRPr lang="en-US" sz="1200" dirty="0"/>
           </a:p>
           <a:p>
-            <a:pPr indent="0" marL="0">
+            <a:pPr marL="0" indent="0">
               <a:buNone/>
             </a:pPr>
             <a:endParaRPr lang="en-US" sz="1200" dirty="0"/>
           </a:p>
           <a:p>
-            <a:pPr indent="0" marL="0">
+            <a:pPr marL="0" indent="0">
               <a:buNone/>
             </a:pPr>
             <a:r>
@@ -2325,6 +2145,13 @@
             <a:prstDash val="solid"/>
           </a:ln>
         </p:spPr>
+        <p:txBody>
+          <a:bodyPr/>
+          <a:lstStyle/>
+          <a:p>
+            <a:endParaRPr lang="en-US"/>
+          </a:p>
+        </p:txBody>
       </p:sp>
       <p:sp>
         <p:nvSpPr>
@@ -2347,7 +2174,7 @@
           <a:bodyPr wrap="square" rtlCol="0" anchor="ctr"/>
           <a:lstStyle/>
           <a:p>
-            <a:pPr indent="0" marL="0">
+            <a:pPr marL="0" indent="0">
               <a:buNone/>
             </a:pPr>
             <a:r>
@@ -2383,7 +2210,7 @@
           <a:bodyPr wrap="square" rtlCol="0" anchor="ctr"/>
           <a:lstStyle/>
           <a:p>
-            <a:pPr indent="0" marL="0">
+            <a:pPr marL="0" indent="0">
               <a:buNone/>
             </a:pPr>
             <a:r>
@@ -2422,7 +2249,7 @@
           <a:bodyPr wrap="square" rtlCol="0" anchor="ctr"/>
           <a:lstStyle/>
           <a:p>
-            <a:pPr indent="0" marL="0">
+            <a:pPr marL="0" indent="0">
               <a:buNone/>
             </a:pPr>
             <a:r>
@@ -2466,6 +2293,13 @@
             <a:prstDash val="solid"/>
           </a:ln>
         </p:spPr>
+        <p:txBody>
+          <a:bodyPr/>
+          <a:lstStyle/>
+          <a:p>
+            <a:endParaRPr lang="en-US"/>
+          </a:p>
+        </p:txBody>
       </p:sp>
       <p:sp>
         <p:nvSpPr>
@@ -2488,7 +2322,7 @@
           <a:bodyPr wrap="square" rtlCol="0" anchor="ctr"/>
           <a:lstStyle/>
           <a:p>
-            <a:pPr indent="0" marL="0">
+            <a:pPr marL="0" indent="0">
               <a:buNone/>
             </a:pPr>
             <a:r>
@@ -2524,7 +2358,7 @@
           <a:bodyPr wrap="square" rtlCol="0" anchor="ctr"/>
           <a:lstStyle/>
           <a:p>
-            <a:pPr indent="0" marL="0">
+            <a:pPr marL="0" indent="0">
               <a:buNone/>
             </a:pPr>
             <a:r>
@@ -2563,7 +2397,7 @@
           <a:bodyPr wrap="square" rtlCol="0" anchor="ctr"/>
           <a:lstStyle/>
           <a:p>
-            <a:pPr indent="0" marL="0">
+            <a:pPr marL="0" indent="0">
               <a:buNone/>
             </a:pPr>
             <a:r>
@@ -2607,6 +2441,13 @@
             <a:prstDash val="solid"/>
           </a:ln>
         </p:spPr>
+        <p:txBody>
+          <a:bodyPr/>
+          <a:lstStyle/>
+          <a:p>
+            <a:endParaRPr lang="en-US"/>
+          </a:p>
+        </p:txBody>
       </p:sp>
       <p:sp>
         <p:nvSpPr>
@@ -2629,7 +2470,7 @@
           <a:bodyPr wrap="square" rtlCol="0" anchor="ctr"/>
           <a:lstStyle/>
           <a:p>
-            <a:pPr indent="0" marL="0">
+            <a:pPr marL="0" indent="0">
               <a:buNone/>
             </a:pPr>
             <a:r>
@@ -2665,7 +2506,7 @@
           <a:bodyPr wrap="square" rtlCol="0" anchor="ctr"/>
           <a:lstStyle/>
           <a:p>
-            <a:pPr indent="0" marL="0">
+            <a:pPr marL="0" indent="0">
               <a:buNone/>
             </a:pPr>
             <a:r>
@@ -2704,7 +2545,7 @@
           <a:bodyPr wrap="square" rtlCol="0" anchor="ctr"/>
           <a:lstStyle/>
           <a:p>
-            <a:pPr indent="0" marL="0">
+            <a:pPr marL="0" indent="0">
               <a:buNone/>
             </a:pPr>
             <a:r>
@@ -2766,6 +2607,13 @@
           </a:solidFill>
           <a:ln/>
         </p:spPr>
+        <p:txBody>
+          <a:bodyPr/>
+          <a:lstStyle/>
+          <a:p>
+            <a:endParaRPr lang="en-US"/>
+          </a:p>
+        </p:txBody>
       </p:sp>
       <p:sp>
         <p:nvSpPr>
@@ -2786,6 +2634,13 @@
           </a:solidFill>
           <a:ln/>
         </p:spPr>
+        <p:txBody>
+          <a:bodyPr/>
+          <a:lstStyle/>
+          <a:p>
+            <a:endParaRPr lang="en-US"/>
+          </a:p>
+        </p:txBody>
       </p:sp>
       <p:sp>
         <p:nvSpPr>
@@ -2808,11 +2663,11 @@
           <a:bodyPr wrap="square" rtlCol="0" anchor="ctr"/>
           <a:lstStyle/>
           <a:p>
-            <a:pPr indent="0" marL="0">
-              <a:buNone/>
-            </a:pPr>
-            <a:r>
-              <a:rPr lang="en-US" sz="800" b="1" spc="300" kern="0" dirty="0">
+            <a:pPr marL="0" indent="0">
+              <a:buNone/>
+            </a:pPr>
+            <a:r>
+              <a:rPr lang="en-US" sz="800" b="1" kern="0" spc="300" dirty="0">
                 <a:solidFill>
                   <a:srgbClr val="F4A261"/>
                 </a:solidFill>
@@ -2847,7 +2702,7 @@
           <a:bodyPr wrap="square" rtlCol="0" anchor="ctr"/>
           <a:lstStyle/>
           <a:p>
-            <a:pPr indent="0" marL="0">
+            <a:pPr marL="0" indent="0">
               <a:buNone/>
             </a:pPr>
             <a:r>
@@ -2886,7 +2741,7 @@
           <a:bodyPr wrap="square" rtlCol="0" anchor="ctr"/>
           <a:lstStyle/>
           <a:p>
-            <a:pPr indent="0" marL="0">
+            <a:pPr marL="0" indent="0">
               <a:buNone/>
             </a:pPr>
             <a:r>
@@ -2925,6 +2780,13 @@
           </a:solidFill>
           <a:ln/>
         </p:spPr>
+        <p:txBody>
+          <a:bodyPr/>
+          <a:lstStyle/>
+          <a:p>
+            <a:endParaRPr lang="en-US"/>
+          </a:p>
+        </p:txBody>
       </p:sp>
       <p:sp>
         <p:nvSpPr>
@@ -2947,11 +2809,11 @@
           <a:bodyPr wrap="square" rtlCol="0" anchor="ctr"/>
           <a:lstStyle/>
           <a:p>
-            <a:pPr algn="ctr" indent="0" marL="0">
-              <a:buNone/>
-            </a:pPr>
-            <a:r>
-              <a:rPr lang="en-US" sz="900" b="1" spc="200" kern="0" dirty="0">
+            <a:pPr marL="0" indent="0" algn="ctr">
+              <a:buNone/>
+            </a:pPr>
+            <a:r>
+              <a:rPr lang="en-US" sz="900" b="1" kern="0" spc="200" dirty="0">
                 <a:solidFill>
                   <a:srgbClr val="F4A261"/>
                 </a:solidFill>
@@ -2986,7 +2848,7 @@
           <a:bodyPr wrap="square" rtlCol="0" anchor="ctr"/>
           <a:lstStyle/>
           <a:p>
-            <a:pPr algn="ctr" indent="0" marL="0">
+            <a:pPr marL="0" indent="0" algn="ctr">
               <a:buNone/>
             </a:pPr>
             <a:r>
@@ -3025,7 +2887,7 @@
           <a:bodyPr wrap="square" rtlCol="0" anchor="ctr"/>
           <a:lstStyle/>
           <a:p>
-            <a:pPr algn="ctr" indent="0" marL="0">
+            <a:pPr marL="0" indent="0" algn="ctr">
               <a:buNone/>
             </a:pPr>
             <a:r>
@@ -3042,7 +2904,7 @@
             <a:endParaRPr lang="en-US" sz="1100" dirty="0"/>
           </a:p>
           <a:p>
-            <a:pPr algn="ctr" indent="0" marL="0">
+            <a:pPr marL="0" indent="0" algn="ctr">
               <a:buNone/>
             </a:pPr>
             <a:r>
@@ -3081,6 +2943,13 @@
           </a:solidFill>
           <a:ln/>
         </p:spPr>
+        <p:txBody>
+          <a:bodyPr/>
+          <a:lstStyle/>
+          <a:p>
+            <a:endParaRPr lang="en-US"/>
+          </a:p>
+        </p:txBody>
       </p:sp>
       <p:sp>
         <p:nvSpPr>
@@ -3103,7 +2972,7 @@
           <a:bodyPr wrap="square" lIns="0" tIns="0" rIns="0" bIns="0" rtlCol="0" anchor="ctr"/>
           <a:lstStyle/>
           <a:p>
-            <a:pPr algn="ctr" indent="0" marL="0">
+            <a:pPr marL="0" indent="0" algn="ctr">
               <a:buNone/>
             </a:pPr>
             <a:r>
@@ -3142,6 +3011,13 @@
           </a:solidFill>
           <a:ln/>
         </p:spPr>
+        <p:txBody>
+          <a:bodyPr/>
+          <a:lstStyle/>
+          <a:p>
+            <a:endParaRPr lang="en-US"/>
+          </a:p>
+        </p:txBody>
       </p:sp>
       <p:sp>
         <p:nvSpPr>
@@ -3164,11 +3040,11 @@
           <a:bodyPr wrap="square" rtlCol="0" anchor="ctr"/>
           <a:lstStyle/>
           <a:p>
-            <a:pPr algn="ctr" indent="0" marL="0">
-              <a:buNone/>
-            </a:pPr>
-            <a:r>
-              <a:rPr lang="en-US" sz="900" b="1" spc="200" kern="0" dirty="0">
+            <a:pPr marL="0" indent="0" algn="ctr">
+              <a:buNone/>
+            </a:pPr>
+            <a:r>
+              <a:rPr lang="en-US" sz="900" b="1" kern="0" spc="200" dirty="0">
                 <a:solidFill>
                   <a:srgbClr val="F4A261"/>
                 </a:solidFill>
@@ -3203,7 +3079,7 @@
           <a:bodyPr wrap="square" rtlCol="0" anchor="ctr"/>
           <a:lstStyle/>
           <a:p>
-            <a:pPr algn="ctr" indent="0" marL="0">
+            <a:pPr marL="0" indent="0" algn="ctr">
               <a:buNone/>
             </a:pPr>
             <a:r>
@@ -3242,7 +3118,7 @@
           <a:bodyPr wrap="square" rtlCol="0" anchor="ctr"/>
           <a:lstStyle/>
           <a:p>
-            <a:pPr algn="ctr" indent="0" marL="0">
+            <a:pPr marL="0" indent="0" algn="ctr">
               <a:buNone/>
             </a:pPr>
             <a:r>
@@ -3259,7 +3135,7 @@
             <a:endParaRPr lang="en-US" sz="1100" dirty="0"/>
           </a:p>
           <a:p>
-            <a:pPr algn="ctr" indent="0" marL="0">
+            <a:pPr marL="0" indent="0" algn="ctr">
               <a:buNone/>
             </a:pPr>
             <a:r>
@@ -3298,6 +3174,13 @@
           </a:solidFill>
           <a:ln/>
         </p:spPr>
+        <p:txBody>
+          <a:bodyPr/>
+          <a:lstStyle/>
+          <a:p>
+            <a:endParaRPr lang="en-US"/>
+          </a:p>
+        </p:txBody>
       </p:sp>
       <p:sp>
         <p:nvSpPr>
@@ -3320,7 +3203,7 @@
           <a:bodyPr wrap="square" lIns="0" tIns="0" rIns="0" bIns="0" rtlCol="0" anchor="ctr"/>
           <a:lstStyle/>
           <a:p>
-            <a:pPr algn="ctr" indent="0" marL="0">
+            <a:pPr marL="0" indent="0" algn="ctr">
               <a:buNone/>
             </a:pPr>
             <a:r>
@@ -3359,6 +3242,13 @@
           </a:solidFill>
           <a:ln/>
         </p:spPr>
+        <p:txBody>
+          <a:bodyPr/>
+          <a:lstStyle/>
+          <a:p>
+            <a:endParaRPr lang="en-US"/>
+          </a:p>
+        </p:txBody>
       </p:sp>
       <p:sp>
         <p:nvSpPr>
@@ -3381,11 +3271,11 @@
           <a:bodyPr wrap="square" rtlCol="0" anchor="ctr"/>
           <a:lstStyle/>
           <a:p>
-            <a:pPr algn="ctr" indent="0" marL="0">
-              <a:buNone/>
-            </a:pPr>
-            <a:r>
-              <a:rPr lang="en-US" sz="900" b="1" spc="200" kern="0" dirty="0">
+            <a:pPr marL="0" indent="0" algn="ctr">
+              <a:buNone/>
+            </a:pPr>
+            <a:r>
+              <a:rPr lang="en-US" sz="900" b="1" kern="0" spc="200" dirty="0">
                 <a:solidFill>
                   <a:srgbClr val="F4A261"/>
                 </a:solidFill>
@@ -3420,7 +3310,7 @@
           <a:bodyPr wrap="square" rtlCol="0" anchor="ctr"/>
           <a:lstStyle/>
           <a:p>
-            <a:pPr algn="ctr" indent="0" marL="0">
+            <a:pPr marL="0" indent="0" algn="ctr">
               <a:buNone/>
             </a:pPr>
             <a:r>
@@ -3437,7 +3327,7 @@
             <a:endParaRPr lang="en-US" sz="1800" dirty="0"/>
           </a:p>
           <a:p>
-            <a:pPr algn="ctr" indent="0" marL="0">
+            <a:pPr marL="0" indent="0" algn="ctr">
               <a:buNone/>
             </a:pPr>
             <a:r>
@@ -3476,7 +3366,7 @@
           <a:bodyPr wrap="square" rtlCol="0" anchor="ctr"/>
           <a:lstStyle/>
           <a:p>
-            <a:pPr algn="ctr" indent="0" marL="0">
+            <a:pPr marL="0" indent="0" algn="ctr">
               <a:buNone/>
             </a:pPr>
             <a:r>
@@ -3493,7 +3383,7 @@
             <a:endParaRPr lang="en-US" sz="1100" dirty="0"/>
           </a:p>
           <a:p>
-            <a:pPr algn="ctr" indent="0" marL="0">
+            <a:pPr marL="0" indent="0" algn="ctr">
               <a:buNone/>
             </a:pPr>
             <a:r>
@@ -3532,6 +3422,13 @@
           </a:solidFill>
           <a:ln/>
         </p:spPr>
+        <p:txBody>
+          <a:bodyPr/>
+          <a:lstStyle/>
+          <a:p>
+            <a:endParaRPr lang="en-US"/>
+          </a:p>
+        </p:txBody>
       </p:sp>
       <p:sp>
         <p:nvSpPr>
@@ -3554,7 +3451,7 @@
           <a:bodyPr wrap="square" lIns="0" tIns="0" rIns="0" bIns="0" rtlCol="0" anchor="ctr"/>
           <a:lstStyle/>
           <a:p>
-            <a:pPr algn="ctr" indent="0" marL="0">
+            <a:pPr marL="0" indent="0" algn="ctr">
               <a:buNone/>
             </a:pPr>
             <a:r>
@@ -3616,6 +3513,13 @@
           </a:solidFill>
           <a:ln/>
         </p:spPr>
+        <p:txBody>
+          <a:bodyPr/>
+          <a:lstStyle/>
+          <a:p>
+            <a:endParaRPr lang="en-US" u="sng" dirty="0"/>
+          </a:p>
+        </p:txBody>
       </p:sp>
       <p:sp>
         <p:nvSpPr>
@@ -3638,11 +3542,11 @@
           <a:bodyPr wrap="square" rtlCol="0" anchor="ctr"/>
           <a:lstStyle/>
           <a:p>
-            <a:pPr indent="0" marL="0">
-              <a:buNone/>
-            </a:pPr>
-            <a:r>
-              <a:rPr lang="en-US" sz="800" b="1" spc="300" kern="0" dirty="0">
+            <a:pPr marL="0" indent="0">
+              <a:buNone/>
+            </a:pPr>
+            <a:r>
+              <a:rPr lang="en-US" sz="800" b="1" kern="0" spc="300" dirty="0">
                 <a:solidFill>
                   <a:srgbClr val="0D4C6B"/>
                 </a:solidFill>
@@ -3677,7 +3581,7 @@
           <a:bodyPr wrap="square" rtlCol="0" anchor="ctr"/>
           <a:lstStyle/>
           <a:p>
-            <a:pPr indent="0" marL="0">
+            <a:pPr marL="0" indent="0">
               <a:buNone/>
             </a:pPr>
             <a:r>
@@ -3721,6 +3625,13 @@
             <a:prstDash val="solid"/>
           </a:ln>
         </p:spPr>
+        <p:txBody>
+          <a:bodyPr/>
+          <a:lstStyle/>
+          <a:p>
+            <a:endParaRPr lang="en-US"/>
+          </a:p>
+        </p:txBody>
       </p:sp>
       <p:sp>
         <p:nvSpPr>
@@ -3743,7 +3654,7 @@
           <a:bodyPr wrap="square" rtlCol="0" anchor="ctr"/>
           <a:lstStyle/>
           <a:p>
-            <a:pPr indent="0" marL="0">
+            <a:pPr marL="0" indent="0">
               <a:buNone/>
             </a:pPr>
             <a:r>
@@ -3782,7 +3693,7 @@
           <a:bodyPr wrap="square" rtlCol="0" anchor="ctr"/>
           <a:lstStyle/>
           <a:p>
-            <a:pPr indent="0" marL="0">
+            <a:pPr marL="0" indent="0">
               <a:buNone/>
             </a:pPr>
             <a:r>
@@ -3821,6 +3732,13 @@
           </a:solidFill>
           <a:ln/>
         </p:spPr>
+        <p:txBody>
+          <a:bodyPr/>
+          <a:lstStyle/>
+          <a:p>
+            <a:endParaRPr lang="en-US"/>
+          </a:p>
+        </p:txBody>
       </p:sp>
       <p:sp>
         <p:nvSpPr>
@@ -3843,7 +3761,7 @@
           <a:bodyPr wrap="square" rtlCol="0" anchor="ctr"/>
           <a:lstStyle/>
           <a:p>
-            <a:pPr indent="0" marL="0">
+            <a:pPr marL="0" indent="0">
               <a:buNone/>
             </a:pPr>
             <a:r>
@@ -3882,7 +3800,7 @@
           <a:bodyPr wrap="square" rtlCol="0" anchor="ctr"/>
           <a:lstStyle/>
           <a:p>
-            <a:pPr indent="0" marL="0">
+            <a:pPr marL="0" indent="0">
               <a:buNone/>
             </a:pPr>
             <a:r>
@@ -3921,6 +3839,13 @@
           </a:solidFill>
           <a:ln/>
         </p:spPr>
+        <p:txBody>
+          <a:bodyPr/>
+          <a:lstStyle/>
+          <a:p>
+            <a:endParaRPr lang="en-US"/>
+          </a:p>
+        </p:txBody>
       </p:sp>
       <p:sp>
         <p:nvSpPr>
@@ -3943,7 +3868,7 @@
           <a:bodyPr wrap="square" rtlCol="0" anchor="ctr"/>
           <a:lstStyle/>
           <a:p>
-            <a:pPr indent="0" marL="0">
+            <a:pPr marL="0" indent="0">
               <a:buNone/>
             </a:pPr>
             <a:r>
@@ -3982,7 +3907,7 @@
           <a:bodyPr wrap="square" rtlCol="0" anchor="ctr"/>
           <a:lstStyle/>
           <a:p>
-            <a:pPr indent="0" marL="0">
+            <a:pPr marL="0" indent="0">
               <a:buNone/>
             </a:pPr>
             <a:r>
@@ -4021,6 +3946,13 @@
           </a:solidFill>
           <a:ln/>
         </p:spPr>
+        <p:txBody>
+          <a:bodyPr/>
+          <a:lstStyle/>
+          <a:p>
+            <a:endParaRPr lang="en-US"/>
+          </a:p>
+        </p:txBody>
       </p:sp>
       <p:sp>
         <p:nvSpPr>
@@ -4043,7 +3975,7 @@
           <a:bodyPr wrap="square" rtlCol="0" anchor="ctr"/>
           <a:lstStyle/>
           <a:p>
-            <a:pPr indent="0" marL="0">
+            <a:pPr marL="0" indent="0">
               <a:buNone/>
             </a:pPr>
             <a:r>
@@ -4082,7 +4014,7 @@
           <a:bodyPr wrap="square" rtlCol="0" anchor="ctr"/>
           <a:lstStyle/>
           <a:p>
-            <a:pPr indent="0" marL="0">
+            <a:pPr marL="0" indent="0">
               <a:buNone/>
             </a:pPr>
             <a:r>
@@ -4126,6 +4058,13 @@
             <a:prstDash val="solid"/>
           </a:ln>
         </p:spPr>
+        <p:txBody>
+          <a:bodyPr/>
+          <a:lstStyle/>
+          <a:p>
+            <a:endParaRPr lang="en-US"/>
+          </a:p>
+        </p:txBody>
       </p:sp>
       <p:sp>
         <p:nvSpPr>
@@ -4148,7 +4087,7 @@
           <a:bodyPr wrap="square" rtlCol="0" anchor="ctr"/>
           <a:lstStyle/>
           <a:p>
-            <a:pPr indent="0" marL="0">
+            <a:pPr marL="0" indent="0">
               <a:buNone/>
             </a:pPr>
             <a:r>
@@ -4187,7 +4126,7 @@
           <a:bodyPr wrap="square" rtlCol="0" anchor="ctr"/>
           <a:lstStyle/>
           <a:p>
-            <a:pPr indent="0" marL="0">
+            <a:pPr marL="0" indent="0">
               <a:buNone/>
             </a:pPr>
             <a:r>
@@ -4205,443 +4144,576 @@
           </a:p>
         </p:txBody>
       </p:sp>
-      <p:sp>
-        <p:nvSpPr>
-          <p:cNvPr id="20" name="Shape 18"/>
-          <p:cNvSpPr/>
-          <p:nvPr/>
-        </p:nvSpPr>
-        <p:spPr>
-          <a:xfrm>
-            <a:off x="4846320" y="2423160"/>
-            <a:ext cx="3566160" cy="621792"/>
-          </a:xfrm>
-          <a:prstGeom prst="roundRect">
-            <a:avLst>
-              <a:gd name="adj" fmla="val 8824"/>
-            </a:avLst>
-          </a:prstGeom>
-          <a:solidFill>
-            <a:srgbClr val="F0F7FA"/>
-          </a:solidFill>
-          <a:ln w="12700">
-            <a:solidFill>
-              <a:srgbClr val="D0E4EE"/>
-            </a:solidFill>
-            <a:prstDash val="solid"/>
-          </a:ln>
-        </p:spPr>
-      </p:sp>
-      <p:sp>
-        <p:nvSpPr>
-          <p:cNvPr id="21" name="Text 19"/>
-          <p:cNvSpPr/>
-          <p:nvPr/>
-        </p:nvSpPr>
-        <p:spPr>
-          <a:xfrm>
-            <a:off x="5029200" y="2468880"/>
-            <a:ext cx="3200400" cy="228600"/>
-          </a:xfrm>
-          <a:prstGeom prst="rect">
-            <a:avLst/>
-          </a:prstGeom>
-          <a:noFill/>
-          <a:ln/>
-        </p:spPr>
-        <p:txBody>
-          <a:bodyPr wrap="square" rtlCol="0" anchor="ctr"/>
-          <a:lstStyle/>
-          <a:p>
-            <a:pPr indent="0" marL="0">
-              <a:buNone/>
-            </a:pPr>
-            <a:r>
-              <a:rPr lang="en-US" sz="1100" b="1" dirty="0">
-                <a:solidFill>
-                  <a:srgbClr val="0D4C6B"/>
-                </a:solidFill>
-                <a:latin typeface="Calibri" pitchFamily="34" charset="0"/>
-                <a:ea typeface="Calibri" pitchFamily="34" charset="-122"/>
-                <a:cs typeface="Calibri" pitchFamily="34" charset="-120"/>
-              </a:rPr>
-              <a:t>1 operator</a:t>
-            </a:r>
-            <a:endParaRPr lang="en-US" sz="1100" dirty="0"/>
-          </a:p>
-        </p:txBody>
-      </p:sp>
-      <p:sp>
-        <p:nvSpPr>
-          <p:cNvPr id="22" name="Text 20"/>
-          <p:cNvSpPr/>
-          <p:nvPr/>
-        </p:nvSpPr>
-        <p:spPr>
-          <a:xfrm>
-            <a:off x="5029200" y="2724912"/>
-            <a:ext cx="3200400" cy="256032"/>
-          </a:xfrm>
-          <a:prstGeom prst="rect">
-            <a:avLst/>
-          </a:prstGeom>
-          <a:noFill/>
-          <a:ln/>
-        </p:spPr>
-        <p:txBody>
-          <a:bodyPr wrap="square" rtlCol="0" anchor="ctr"/>
-          <a:lstStyle/>
-          <a:p>
-            <a:pPr indent="0" marL="0">
-              <a:buNone/>
-            </a:pPr>
-            <a:r>
-              <a:rPr lang="en-US" sz="900" dirty="0">
-                <a:solidFill>
-                  <a:srgbClr val="0D1B2A"/>
-                </a:solidFill>
-                <a:latin typeface="Calibri" pitchFamily="34" charset="0"/>
-                <a:ea typeface="Calibri" pitchFamily="34" charset="-122"/>
-                <a:cs typeface="Calibri" pitchFamily="34" charset="-120"/>
-              </a:rPr>
-              <a:t>Excluded — no reference group</a:t>
-            </a:r>
-            <a:endParaRPr lang="en-US" sz="900" dirty="0"/>
-          </a:p>
-        </p:txBody>
-      </p:sp>
-      <p:sp>
-        <p:nvSpPr>
-          <p:cNvPr id="23" name="Shape 21"/>
-          <p:cNvSpPr/>
-          <p:nvPr/>
-        </p:nvSpPr>
-        <p:spPr>
-          <a:xfrm>
-            <a:off x="4846320" y="3172968"/>
-            <a:ext cx="3566160" cy="621792"/>
-          </a:xfrm>
-          <a:prstGeom prst="roundRect">
-            <a:avLst>
-              <a:gd name="adj" fmla="val 8824"/>
-            </a:avLst>
-          </a:prstGeom>
-          <a:solidFill>
-            <a:srgbClr val="F0F7FA"/>
-          </a:solidFill>
-          <a:ln w="12700">
-            <a:solidFill>
-              <a:srgbClr val="D0E4EE"/>
-            </a:solidFill>
-            <a:prstDash val="solid"/>
-          </a:ln>
-        </p:spPr>
-      </p:sp>
-      <p:sp>
-        <p:nvSpPr>
-          <p:cNvPr id="24" name="Text 22"/>
-          <p:cNvSpPr/>
-          <p:nvPr/>
-        </p:nvSpPr>
-        <p:spPr>
-          <a:xfrm>
-            <a:off x="5029200" y="3218688"/>
-            <a:ext cx="3200400" cy="228600"/>
-          </a:xfrm>
-          <a:prstGeom prst="rect">
-            <a:avLst/>
-          </a:prstGeom>
-          <a:noFill/>
-          <a:ln/>
-        </p:spPr>
-        <p:txBody>
-          <a:bodyPr wrap="square" rtlCol="0" anchor="ctr"/>
-          <a:lstStyle/>
-          <a:p>
-            <a:pPr indent="0" marL="0">
-              <a:buNone/>
-            </a:pPr>
-            <a:r>
-              <a:rPr lang="en-US" sz="1100" b="1" dirty="0">
-                <a:solidFill>
-                  <a:srgbClr val="0D4C6B"/>
-                </a:solidFill>
-                <a:latin typeface="Calibri" pitchFamily="34" charset="0"/>
-                <a:ea typeface="Calibri" pitchFamily="34" charset="-122"/>
-                <a:cs typeface="Calibri" pitchFamily="34" charset="-120"/>
-              </a:rPr>
-              <a:t>2 operators</a:t>
-            </a:r>
-            <a:endParaRPr lang="en-US" sz="1100" dirty="0"/>
-          </a:p>
-        </p:txBody>
-      </p:sp>
-      <p:sp>
-        <p:nvSpPr>
-          <p:cNvPr id="25" name="Text 23"/>
-          <p:cNvSpPr/>
-          <p:nvPr/>
-        </p:nvSpPr>
-        <p:spPr>
-          <a:xfrm>
-            <a:off x="5029200" y="3474720"/>
-            <a:ext cx="3200400" cy="256032"/>
-          </a:xfrm>
-          <a:prstGeom prst="rect">
-            <a:avLst/>
-          </a:prstGeom>
-          <a:noFill/>
-          <a:ln/>
-        </p:spPr>
-        <p:txBody>
-          <a:bodyPr wrap="square" rtlCol="0" anchor="ctr"/>
-          <a:lstStyle/>
-          <a:p>
-            <a:pPr indent="0" marL="0">
-              <a:buNone/>
-            </a:pPr>
-            <a:r>
-              <a:rPr lang="en-US" sz="900" dirty="0">
-                <a:solidFill>
-                  <a:srgbClr val="0D1B2A"/>
-                </a:solidFill>
-                <a:latin typeface="Calibri" pitchFamily="34" charset="0"/>
-                <a:ea typeface="Calibri" pitchFamily="34" charset="-122"/>
-                <a:cs typeface="Calibri" pitchFamily="34" charset="-120"/>
-              </a:rPr>
-              <a:t>Volume ratio ≥ 66% required</a:t>
-            </a:r>
-            <a:endParaRPr lang="en-US" sz="900" dirty="0"/>
-          </a:p>
-        </p:txBody>
-      </p:sp>
-      <p:sp>
-        <p:nvSpPr>
-          <p:cNvPr id="26" name="Shape 24"/>
-          <p:cNvSpPr/>
-          <p:nvPr/>
-        </p:nvSpPr>
-        <p:spPr>
-          <a:xfrm>
-            <a:off x="4846320" y="3922776"/>
-            <a:ext cx="3566160" cy="621792"/>
-          </a:xfrm>
-          <a:prstGeom prst="roundRect">
-            <a:avLst>
-              <a:gd name="adj" fmla="val 8824"/>
-            </a:avLst>
-          </a:prstGeom>
-          <a:solidFill>
-            <a:srgbClr val="F0F7FA"/>
-          </a:solidFill>
-          <a:ln w="12700">
-            <a:solidFill>
-              <a:srgbClr val="D0E4EE"/>
-            </a:solidFill>
-            <a:prstDash val="solid"/>
-          </a:ln>
-        </p:spPr>
-      </p:sp>
-      <p:sp>
-        <p:nvSpPr>
-          <p:cNvPr id="27" name="Text 25"/>
-          <p:cNvSpPr/>
-          <p:nvPr/>
-        </p:nvSpPr>
-        <p:spPr>
-          <a:xfrm>
-            <a:off x="5029200" y="3968496"/>
-            <a:ext cx="3200400" cy="228600"/>
-          </a:xfrm>
-          <a:prstGeom prst="rect">
-            <a:avLst/>
-          </a:prstGeom>
-          <a:noFill/>
-          <a:ln/>
-        </p:spPr>
-        <p:txBody>
-          <a:bodyPr wrap="square" rtlCol="0" anchor="ctr"/>
-          <a:lstStyle/>
-          <a:p>
-            <a:pPr indent="0" marL="0">
-              <a:buNone/>
-            </a:pPr>
-            <a:r>
-              <a:rPr lang="en-US" sz="1100" b="1" dirty="0">
-                <a:solidFill>
-                  <a:srgbClr val="0D4C6B"/>
-                </a:solidFill>
-                <a:latin typeface="Calibri" pitchFamily="34" charset="0"/>
-                <a:ea typeface="Calibri" pitchFamily="34" charset="-122"/>
-                <a:cs typeface="Calibri" pitchFamily="34" charset="-120"/>
-              </a:rPr>
-              <a:t>≥ 3 operators</a:t>
-            </a:r>
-            <a:endParaRPr lang="en-US" sz="1100" dirty="0"/>
-          </a:p>
-        </p:txBody>
-      </p:sp>
-      <p:sp>
-        <p:nvSpPr>
-          <p:cNvPr id="28" name="Text 26"/>
-          <p:cNvSpPr/>
-          <p:nvPr/>
-        </p:nvSpPr>
-        <p:spPr>
-          <a:xfrm>
-            <a:off x="5029200" y="4224528"/>
-            <a:ext cx="3200400" cy="256032"/>
-          </a:xfrm>
-          <a:prstGeom prst="rect">
-            <a:avLst/>
-          </a:prstGeom>
-          <a:noFill/>
-          <a:ln/>
-        </p:spPr>
-        <p:txBody>
-          <a:bodyPr wrap="square" rtlCol="0" anchor="ctr"/>
-          <a:lstStyle/>
-          <a:p>
-            <a:pPr indent="0" marL="0">
-              <a:buNone/>
-            </a:pPr>
-            <a:r>
-              <a:rPr lang="en-US" sz="900" dirty="0">
-                <a:solidFill>
-                  <a:srgbClr val="0D1B2A"/>
-                </a:solidFill>
-                <a:latin typeface="Calibri" pitchFamily="34" charset="0"/>
-                <a:ea typeface="Calibri" pitchFamily="34" charset="-122"/>
-                <a:cs typeface="Calibri" pitchFamily="34" charset="-120"/>
-              </a:rPr>
-              <a:t>Must reach P25 of team volume</a:t>
-            </a:r>
-            <a:endParaRPr lang="en-US" sz="900" dirty="0"/>
-          </a:p>
-        </p:txBody>
-      </p:sp>
-      <p:sp>
-        <p:nvSpPr>
-          <p:cNvPr id="29" name="Shape 27"/>
-          <p:cNvSpPr/>
-          <p:nvPr/>
-        </p:nvSpPr>
-        <p:spPr>
-          <a:xfrm>
-            <a:off x="4846320" y="4672584"/>
-            <a:ext cx="3566160" cy="713232"/>
-          </a:xfrm>
-          <a:prstGeom prst="roundRect">
-            <a:avLst>
-              <a:gd name="adj" fmla="val 7692"/>
-            </a:avLst>
-          </a:prstGeom>
-          <a:solidFill>
-            <a:srgbClr val="0D4C6B"/>
-          </a:solidFill>
-          <a:ln w="12700">
-            <a:solidFill>
-              <a:srgbClr val="D0E4EE"/>
-            </a:solidFill>
-            <a:prstDash val="solid"/>
-          </a:ln>
-        </p:spPr>
-      </p:sp>
-      <p:sp>
-        <p:nvSpPr>
-          <p:cNvPr id="30" name="Text 28"/>
-          <p:cNvSpPr/>
-          <p:nvPr/>
-        </p:nvSpPr>
-        <p:spPr>
-          <a:xfrm>
-            <a:off x="5029200" y="4718304"/>
-            <a:ext cx="3200400" cy="228600"/>
-          </a:xfrm>
-          <a:prstGeom prst="rect">
-            <a:avLst/>
-          </a:prstGeom>
-          <a:noFill/>
-          <a:ln/>
-        </p:spPr>
-        <p:txBody>
-          <a:bodyPr wrap="square" rtlCol="0" anchor="ctr"/>
-          <a:lstStyle/>
-          <a:p>
-            <a:pPr indent="0" marL="0">
-              <a:buNone/>
-            </a:pPr>
-            <a:r>
-              <a:rPr lang="en-US" sz="1100" b="1" dirty="0">
-                <a:solidFill>
-                  <a:srgbClr val="F4A261"/>
-                </a:solidFill>
-                <a:latin typeface="Calibri" pitchFamily="34" charset="0"/>
-                <a:ea typeface="Calibri" pitchFamily="34" charset="-122"/>
-                <a:cs typeface="Calibri" pitchFamily="34" charset="-120"/>
-              </a:rPr>
-              <a:t>Global floor</a:t>
-            </a:r>
-            <a:endParaRPr lang="en-US" sz="1100" dirty="0"/>
-          </a:p>
-        </p:txBody>
-      </p:sp>
-      <p:sp>
-        <p:nvSpPr>
-          <p:cNvPr id="31" name="Text 29"/>
-          <p:cNvSpPr/>
-          <p:nvPr/>
-        </p:nvSpPr>
-        <p:spPr>
-          <a:xfrm>
-            <a:off x="5029200" y="4974336"/>
-            <a:ext cx="3200400" cy="384048"/>
-          </a:xfrm>
-          <a:prstGeom prst="rect">
-            <a:avLst/>
-          </a:prstGeom>
-          <a:noFill/>
-          <a:ln/>
-        </p:spPr>
-        <p:txBody>
-          <a:bodyPr wrap="square" rtlCol="0" anchor="ctr"/>
-          <a:lstStyle/>
-          <a:p>
-            <a:pPr indent="0" marL="0">
-              <a:buNone/>
-            </a:pPr>
-            <a:r>
-              <a:rPr lang="en-US" sz="900" dirty="0">
-                <a:solidFill>
-                  <a:srgbClr val="F0F4F8"/>
-                </a:solidFill>
-                <a:latin typeface="Calibri" pitchFamily="34" charset="0"/>
-                <a:ea typeface="Calibri" pitchFamily="34" charset="-122"/>
-                <a:cs typeface="Calibri" pitchFamily="34" charset="-120"/>
-              </a:rPr>
-              <a:t>17 calls inbound · 28 calls/wk outbound</a:t>
-            </a:r>
-            <a:endParaRPr lang="en-US" sz="900" dirty="0"/>
-          </a:p>
-          <a:p>
-            <a:pPr indent="0" marL="0">
-              <a:buNone/>
-            </a:pPr>
-            <a:r>
-              <a:rPr lang="en-US" sz="900" dirty="0">
-                <a:solidFill>
-                  <a:srgbClr val="F0F4F8"/>
-                </a:solidFill>
-                <a:latin typeface="Calibri" pitchFamily="34" charset="0"/>
-                <a:ea typeface="Calibri" pitchFamily="34" charset="-122"/>
-                <a:cs typeface="Calibri" pitchFamily="34" charset="-120"/>
-              </a:rPr>
-              <a:t>(median of distribution per EDA)</a:t>
-            </a:r>
-            <a:endParaRPr lang="en-US" sz="900" dirty="0"/>
-          </a:p>
-        </p:txBody>
-      </p:sp>
+      <p:grpSp>
+        <p:nvGrpSpPr>
+          <p:cNvPr id="36" name="Agrupar 35">
+            <a:extLst>
+              <a:ext uri="{FF2B5EF4-FFF2-40B4-BE49-F238E27FC236}">
+                <a16:creationId xmlns:a16="http://schemas.microsoft.com/office/drawing/2014/main" id="{D11603FA-9F6D-9B91-DF5D-28F69F82022B}"/>
+              </a:ext>
+            </a:extLst>
+          </p:cNvPr>
+          <p:cNvGrpSpPr/>
+          <p:nvPr/>
+        </p:nvGrpSpPr>
+        <p:grpSpPr>
+          <a:xfrm>
+            <a:off x="4937760" y="2468881"/>
+            <a:ext cx="3383280" cy="2011680"/>
+            <a:chOff x="4846320" y="2423160"/>
+            <a:chExt cx="3566160" cy="2962656"/>
+          </a:xfrm>
+        </p:grpSpPr>
+        <p:grpSp>
+          <p:nvGrpSpPr>
+            <p:cNvPr id="32" name="Agrupar 31">
+              <a:extLst>
+                <a:ext uri="{FF2B5EF4-FFF2-40B4-BE49-F238E27FC236}">
+                  <a16:creationId xmlns:a16="http://schemas.microsoft.com/office/drawing/2014/main" id="{4218F9DD-D794-D854-9D94-30805F2508E2}"/>
+                </a:ext>
+              </a:extLst>
+            </p:cNvPr>
+            <p:cNvGrpSpPr/>
+            <p:nvPr/>
+          </p:nvGrpSpPr>
+          <p:grpSpPr>
+            <a:xfrm>
+              <a:off x="4846320" y="2423160"/>
+              <a:ext cx="3566160" cy="621792"/>
+              <a:chOff x="4846320" y="2423160"/>
+              <a:chExt cx="3566160" cy="621792"/>
+            </a:xfrm>
+          </p:grpSpPr>
+          <p:sp>
+            <p:nvSpPr>
+              <p:cNvPr id="20" name="Shape 18"/>
+              <p:cNvSpPr/>
+              <p:nvPr/>
+            </p:nvSpPr>
+            <p:spPr>
+              <a:xfrm>
+                <a:off x="4846320" y="2423160"/>
+                <a:ext cx="3566160" cy="621792"/>
+              </a:xfrm>
+              <a:prstGeom prst="roundRect">
+                <a:avLst>
+                  <a:gd name="adj" fmla="val 8824"/>
+                </a:avLst>
+              </a:prstGeom>
+              <a:solidFill>
+                <a:srgbClr val="F0F7FA"/>
+              </a:solidFill>
+              <a:ln w="12700">
+                <a:solidFill>
+                  <a:srgbClr val="D0E4EE"/>
+                </a:solidFill>
+                <a:prstDash val="solid"/>
+              </a:ln>
+            </p:spPr>
+            <p:txBody>
+              <a:bodyPr/>
+              <a:lstStyle/>
+              <a:p>
+                <a:endParaRPr lang="en-US"/>
+              </a:p>
+            </p:txBody>
+          </p:sp>
+          <p:sp>
+            <p:nvSpPr>
+              <p:cNvPr id="21" name="Text 19"/>
+              <p:cNvSpPr/>
+              <p:nvPr/>
+            </p:nvSpPr>
+            <p:spPr>
+              <a:xfrm>
+                <a:off x="5029200" y="2468880"/>
+                <a:ext cx="3200400" cy="228600"/>
+              </a:xfrm>
+              <a:prstGeom prst="rect">
+                <a:avLst/>
+              </a:prstGeom>
+              <a:noFill/>
+              <a:ln/>
+            </p:spPr>
+            <p:txBody>
+              <a:bodyPr wrap="square" rtlCol="0" anchor="ctr"/>
+              <a:lstStyle/>
+              <a:p>
+                <a:pPr marL="0" indent="0">
+                  <a:buNone/>
+                </a:pPr>
+                <a:r>
+                  <a:rPr lang="en-US" sz="1050" b="1" dirty="0">
+                    <a:solidFill>
+                      <a:srgbClr val="0D4C6B"/>
+                    </a:solidFill>
+                    <a:latin typeface="Calibri" pitchFamily="34" charset="0"/>
+                    <a:ea typeface="Calibri" pitchFamily="34" charset="-122"/>
+                    <a:cs typeface="Calibri" pitchFamily="34" charset="-120"/>
+                  </a:rPr>
+                  <a:t>1 operator</a:t>
+                </a:r>
+                <a:endParaRPr lang="en-US" sz="1050" dirty="0"/>
+              </a:p>
+            </p:txBody>
+          </p:sp>
+          <p:sp>
+            <p:nvSpPr>
+              <p:cNvPr id="22" name="Text 20"/>
+              <p:cNvSpPr/>
+              <p:nvPr/>
+            </p:nvSpPr>
+            <p:spPr>
+              <a:xfrm>
+                <a:off x="5029200" y="2724912"/>
+                <a:ext cx="3200400" cy="256032"/>
+              </a:xfrm>
+              <a:prstGeom prst="rect">
+                <a:avLst/>
+              </a:prstGeom>
+              <a:noFill/>
+              <a:ln/>
+            </p:spPr>
+            <p:txBody>
+              <a:bodyPr wrap="square" rtlCol="0" anchor="ctr"/>
+              <a:lstStyle/>
+              <a:p>
+                <a:pPr marL="0" indent="0">
+                  <a:buNone/>
+                </a:pPr>
+                <a:r>
+                  <a:rPr lang="en-US" sz="800" dirty="0">
+                    <a:solidFill>
+                      <a:srgbClr val="0D1B2A"/>
+                    </a:solidFill>
+                    <a:latin typeface="Calibri" pitchFamily="34" charset="0"/>
+                    <a:ea typeface="Calibri" pitchFamily="34" charset="-122"/>
+                    <a:cs typeface="Calibri" pitchFamily="34" charset="-120"/>
+                  </a:rPr>
+                  <a:t>Excluded — no reference group</a:t>
+                </a:r>
+                <a:endParaRPr lang="en-US" sz="800" dirty="0"/>
+              </a:p>
+            </p:txBody>
+          </p:sp>
+        </p:grpSp>
+        <p:grpSp>
+          <p:nvGrpSpPr>
+            <p:cNvPr id="33" name="Agrupar 32">
+              <a:extLst>
+                <a:ext uri="{FF2B5EF4-FFF2-40B4-BE49-F238E27FC236}">
+                  <a16:creationId xmlns:a16="http://schemas.microsoft.com/office/drawing/2014/main" id="{439D1022-F656-48D5-801F-771B45D31A56}"/>
+                </a:ext>
+              </a:extLst>
+            </p:cNvPr>
+            <p:cNvGrpSpPr/>
+            <p:nvPr/>
+          </p:nvGrpSpPr>
+          <p:grpSpPr>
+            <a:xfrm>
+              <a:off x="4846320" y="3172968"/>
+              <a:ext cx="3566160" cy="621792"/>
+              <a:chOff x="4846320" y="3172968"/>
+              <a:chExt cx="3566160" cy="621792"/>
+            </a:xfrm>
+          </p:grpSpPr>
+          <p:sp>
+            <p:nvSpPr>
+              <p:cNvPr id="23" name="Shape 21"/>
+              <p:cNvSpPr/>
+              <p:nvPr/>
+            </p:nvSpPr>
+            <p:spPr>
+              <a:xfrm>
+                <a:off x="4846320" y="3172968"/>
+                <a:ext cx="3566160" cy="621792"/>
+              </a:xfrm>
+              <a:prstGeom prst="roundRect">
+                <a:avLst>
+                  <a:gd name="adj" fmla="val 8824"/>
+                </a:avLst>
+              </a:prstGeom>
+              <a:solidFill>
+                <a:srgbClr val="F0F7FA"/>
+              </a:solidFill>
+              <a:ln w="12700">
+                <a:solidFill>
+                  <a:srgbClr val="D0E4EE"/>
+                </a:solidFill>
+                <a:prstDash val="solid"/>
+              </a:ln>
+            </p:spPr>
+            <p:txBody>
+              <a:bodyPr/>
+              <a:lstStyle/>
+              <a:p>
+                <a:endParaRPr lang="en-US"/>
+              </a:p>
+            </p:txBody>
+          </p:sp>
+          <p:sp>
+            <p:nvSpPr>
+              <p:cNvPr id="24" name="Text 22"/>
+              <p:cNvSpPr/>
+              <p:nvPr/>
+            </p:nvSpPr>
+            <p:spPr>
+              <a:xfrm>
+                <a:off x="5029200" y="3218688"/>
+                <a:ext cx="3200400" cy="228600"/>
+              </a:xfrm>
+              <a:prstGeom prst="rect">
+                <a:avLst/>
+              </a:prstGeom>
+              <a:noFill/>
+              <a:ln/>
+            </p:spPr>
+            <p:txBody>
+              <a:bodyPr wrap="square" rtlCol="0" anchor="ctr"/>
+              <a:lstStyle/>
+              <a:p>
+                <a:pPr marL="0" indent="0">
+                  <a:buNone/>
+                </a:pPr>
+                <a:r>
+                  <a:rPr lang="en-US" sz="1050" b="1" dirty="0">
+                    <a:solidFill>
+                      <a:srgbClr val="0D4C6B"/>
+                    </a:solidFill>
+                    <a:latin typeface="Calibri" pitchFamily="34" charset="0"/>
+                    <a:ea typeface="Calibri" pitchFamily="34" charset="-122"/>
+                    <a:cs typeface="Calibri" pitchFamily="34" charset="-120"/>
+                  </a:rPr>
+                  <a:t>2 operators</a:t>
+                </a:r>
+                <a:endParaRPr lang="en-US" sz="1050" dirty="0"/>
+              </a:p>
+            </p:txBody>
+          </p:sp>
+          <p:sp>
+            <p:nvSpPr>
+              <p:cNvPr id="25" name="Text 23"/>
+              <p:cNvSpPr/>
+              <p:nvPr/>
+            </p:nvSpPr>
+            <p:spPr>
+              <a:xfrm>
+                <a:off x="5029200" y="3474720"/>
+                <a:ext cx="3200400" cy="256032"/>
+              </a:xfrm>
+              <a:prstGeom prst="rect">
+                <a:avLst/>
+              </a:prstGeom>
+              <a:noFill/>
+              <a:ln/>
+            </p:spPr>
+            <p:txBody>
+              <a:bodyPr wrap="square" rtlCol="0" anchor="ctr"/>
+              <a:lstStyle/>
+              <a:p>
+                <a:pPr marL="0" indent="0">
+                  <a:buNone/>
+                </a:pPr>
+                <a:r>
+                  <a:rPr lang="en-US" sz="800" dirty="0">
+                    <a:solidFill>
+                      <a:srgbClr val="0D1B2A"/>
+                    </a:solidFill>
+                    <a:latin typeface="Calibri" pitchFamily="34" charset="0"/>
+                    <a:ea typeface="Calibri" pitchFamily="34" charset="-122"/>
+                    <a:cs typeface="Calibri" pitchFamily="34" charset="-120"/>
+                  </a:rPr>
+                  <a:t>Volume ratio ≥ 66% required</a:t>
+                </a:r>
+                <a:endParaRPr lang="en-US" sz="800" dirty="0"/>
+              </a:p>
+            </p:txBody>
+          </p:sp>
+        </p:grpSp>
+        <p:grpSp>
+          <p:nvGrpSpPr>
+            <p:cNvPr id="34" name="Agrupar 33">
+              <a:extLst>
+                <a:ext uri="{FF2B5EF4-FFF2-40B4-BE49-F238E27FC236}">
+                  <a16:creationId xmlns:a16="http://schemas.microsoft.com/office/drawing/2014/main" id="{0A37C23A-BE0D-2693-F980-9CB77DEDAA9B}"/>
+                </a:ext>
+              </a:extLst>
+            </p:cNvPr>
+            <p:cNvGrpSpPr/>
+            <p:nvPr/>
+          </p:nvGrpSpPr>
+          <p:grpSpPr>
+            <a:xfrm>
+              <a:off x="4846320" y="3922776"/>
+              <a:ext cx="3566160" cy="621792"/>
+              <a:chOff x="4846320" y="3922776"/>
+              <a:chExt cx="3566160" cy="621792"/>
+            </a:xfrm>
+          </p:grpSpPr>
+          <p:sp>
+            <p:nvSpPr>
+              <p:cNvPr id="26" name="Shape 24"/>
+              <p:cNvSpPr/>
+              <p:nvPr/>
+            </p:nvSpPr>
+            <p:spPr>
+              <a:xfrm>
+                <a:off x="4846320" y="3922776"/>
+                <a:ext cx="3566160" cy="621792"/>
+              </a:xfrm>
+              <a:prstGeom prst="roundRect">
+                <a:avLst>
+                  <a:gd name="adj" fmla="val 8824"/>
+                </a:avLst>
+              </a:prstGeom>
+              <a:solidFill>
+                <a:srgbClr val="F0F7FA"/>
+              </a:solidFill>
+              <a:ln w="12700">
+                <a:solidFill>
+                  <a:srgbClr val="D0E4EE"/>
+                </a:solidFill>
+                <a:prstDash val="solid"/>
+              </a:ln>
+            </p:spPr>
+            <p:txBody>
+              <a:bodyPr/>
+              <a:lstStyle/>
+              <a:p>
+                <a:endParaRPr lang="en-US"/>
+              </a:p>
+            </p:txBody>
+          </p:sp>
+          <p:sp>
+            <p:nvSpPr>
+              <p:cNvPr id="27" name="Text 25"/>
+              <p:cNvSpPr/>
+              <p:nvPr/>
+            </p:nvSpPr>
+            <p:spPr>
+              <a:xfrm>
+                <a:off x="5029200" y="3968496"/>
+                <a:ext cx="3200400" cy="228600"/>
+              </a:xfrm>
+              <a:prstGeom prst="rect">
+                <a:avLst/>
+              </a:prstGeom>
+              <a:noFill/>
+              <a:ln/>
+            </p:spPr>
+            <p:txBody>
+              <a:bodyPr wrap="square" rtlCol="0" anchor="ctr"/>
+              <a:lstStyle/>
+              <a:p>
+                <a:pPr marL="0" indent="0">
+                  <a:buNone/>
+                </a:pPr>
+                <a:r>
+                  <a:rPr lang="en-US" sz="1050" b="1" dirty="0">
+                    <a:solidFill>
+                      <a:srgbClr val="0D4C6B"/>
+                    </a:solidFill>
+                    <a:latin typeface="Calibri" pitchFamily="34" charset="0"/>
+                    <a:ea typeface="Calibri" pitchFamily="34" charset="-122"/>
+                    <a:cs typeface="Calibri" pitchFamily="34" charset="-120"/>
+                  </a:rPr>
+                  <a:t>≥ 3 operators</a:t>
+                </a:r>
+                <a:endParaRPr lang="en-US" sz="1050" dirty="0"/>
+              </a:p>
+            </p:txBody>
+          </p:sp>
+          <p:sp>
+            <p:nvSpPr>
+              <p:cNvPr id="28" name="Text 26"/>
+              <p:cNvSpPr/>
+              <p:nvPr/>
+            </p:nvSpPr>
+            <p:spPr>
+              <a:xfrm>
+                <a:off x="5029200" y="4224528"/>
+                <a:ext cx="3200400" cy="256032"/>
+              </a:xfrm>
+              <a:prstGeom prst="rect">
+                <a:avLst/>
+              </a:prstGeom>
+              <a:noFill/>
+              <a:ln/>
+            </p:spPr>
+            <p:txBody>
+              <a:bodyPr wrap="square" rtlCol="0" anchor="ctr"/>
+              <a:lstStyle/>
+              <a:p>
+                <a:pPr marL="0" indent="0">
+                  <a:buNone/>
+                </a:pPr>
+                <a:r>
+                  <a:rPr lang="en-US" sz="800" dirty="0">
+                    <a:solidFill>
+                      <a:srgbClr val="0D1B2A"/>
+                    </a:solidFill>
+                    <a:latin typeface="Calibri" pitchFamily="34" charset="0"/>
+                    <a:ea typeface="Calibri" pitchFamily="34" charset="-122"/>
+                    <a:cs typeface="Calibri" pitchFamily="34" charset="-120"/>
+                  </a:rPr>
+                  <a:t>Must reach P25 of team volume</a:t>
+                </a:r>
+                <a:endParaRPr lang="en-US" sz="800" dirty="0"/>
+              </a:p>
+            </p:txBody>
+          </p:sp>
+        </p:grpSp>
+        <p:grpSp>
+          <p:nvGrpSpPr>
+            <p:cNvPr id="35" name="Agrupar 34">
+              <a:extLst>
+                <a:ext uri="{FF2B5EF4-FFF2-40B4-BE49-F238E27FC236}">
+                  <a16:creationId xmlns:a16="http://schemas.microsoft.com/office/drawing/2014/main" id="{02BE13D8-8507-D11A-D3F8-DDDE3DFDC64D}"/>
+                </a:ext>
+              </a:extLst>
+            </p:cNvPr>
+            <p:cNvGrpSpPr/>
+            <p:nvPr/>
+          </p:nvGrpSpPr>
+          <p:grpSpPr>
+            <a:xfrm>
+              <a:off x="4846320" y="4672584"/>
+              <a:ext cx="3566160" cy="713232"/>
+              <a:chOff x="4846320" y="4672584"/>
+              <a:chExt cx="3566160" cy="713232"/>
+            </a:xfrm>
+          </p:grpSpPr>
+          <p:sp>
+            <p:nvSpPr>
+              <p:cNvPr id="29" name="Shape 27"/>
+              <p:cNvSpPr/>
+              <p:nvPr/>
+            </p:nvSpPr>
+            <p:spPr>
+              <a:xfrm>
+                <a:off x="4846320" y="4672584"/>
+                <a:ext cx="3566160" cy="713232"/>
+              </a:xfrm>
+              <a:prstGeom prst="roundRect">
+                <a:avLst>
+                  <a:gd name="adj" fmla="val 7692"/>
+                </a:avLst>
+              </a:prstGeom>
+              <a:solidFill>
+                <a:srgbClr val="0D4C6B"/>
+              </a:solidFill>
+              <a:ln w="12700">
+                <a:solidFill>
+                  <a:srgbClr val="D0E4EE"/>
+                </a:solidFill>
+                <a:prstDash val="solid"/>
+              </a:ln>
+            </p:spPr>
+            <p:txBody>
+              <a:bodyPr/>
+              <a:lstStyle/>
+              <a:p>
+                <a:endParaRPr lang="en-US"/>
+              </a:p>
+            </p:txBody>
+          </p:sp>
+          <p:sp>
+            <p:nvSpPr>
+              <p:cNvPr id="30" name="Text 28"/>
+              <p:cNvSpPr/>
+              <p:nvPr/>
+            </p:nvSpPr>
+            <p:spPr>
+              <a:xfrm>
+                <a:off x="5029200" y="4718304"/>
+                <a:ext cx="3200400" cy="228600"/>
+              </a:xfrm>
+              <a:prstGeom prst="rect">
+                <a:avLst/>
+              </a:prstGeom>
+              <a:noFill/>
+              <a:ln/>
+            </p:spPr>
+            <p:txBody>
+              <a:bodyPr wrap="square" rtlCol="0" anchor="ctr"/>
+              <a:lstStyle/>
+              <a:p>
+                <a:pPr marL="0" indent="0">
+                  <a:buNone/>
+                </a:pPr>
+                <a:r>
+                  <a:rPr lang="en-US" sz="1050" b="1" dirty="0">
+                    <a:solidFill>
+                      <a:srgbClr val="F4A261"/>
+                    </a:solidFill>
+                    <a:latin typeface="Calibri" pitchFamily="34" charset="0"/>
+                    <a:ea typeface="Calibri" pitchFamily="34" charset="-122"/>
+                    <a:cs typeface="Calibri" pitchFamily="34" charset="-120"/>
+                  </a:rPr>
+                  <a:t>Global floor</a:t>
+                </a:r>
+                <a:endParaRPr lang="en-US" sz="1050" dirty="0"/>
+              </a:p>
+            </p:txBody>
+          </p:sp>
+          <p:sp>
+            <p:nvSpPr>
+              <p:cNvPr id="31" name="Text 29"/>
+              <p:cNvSpPr/>
+              <p:nvPr/>
+            </p:nvSpPr>
+            <p:spPr>
+              <a:xfrm>
+                <a:off x="5029200" y="4974336"/>
+                <a:ext cx="3200400" cy="384048"/>
+              </a:xfrm>
+              <a:prstGeom prst="rect">
+                <a:avLst/>
+              </a:prstGeom>
+              <a:noFill/>
+              <a:ln/>
+            </p:spPr>
+            <p:txBody>
+              <a:bodyPr wrap="square" rtlCol="0" anchor="ctr"/>
+              <a:lstStyle/>
+              <a:p>
+                <a:pPr marL="0" indent="0">
+                  <a:buNone/>
+                </a:pPr>
+                <a:r>
+                  <a:rPr lang="en-US" sz="800" dirty="0">
+                    <a:solidFill>
+                      <a:srgbClr val="F0F4F8"/>
+                    </a:solidFill>
+                    <a:latin typeface="Calibri" pitchFamily="34" charset="0"/>
+                    <a:ea typeface="Calibri" pitchFamily="34" charset="-122"/>
+                    <a:cs typeface="Calibri" pitchFamily="34" charset="-120"/>
+                  </a:rPr>
+                  <a:t>17 calls inbound · 28 calls/wk outbound</a:t>
+                </a:r>
+                <a:endParaRPr lang="en-US" sz="800" dirty="0"/>
+              </a:p>
+              <a:p>
+                <a:pPr marL="0" indent="0">
+                  <a:buNone/>
+                </a:pPr>
+                <a:r>
+                  <a:rPr lang="en-US" sz="800" dirty="0">
+                    <a:solidFill>
+                      <a:srgbClr val="F0F4F8"/>
+                    </a:solidFill>
+                    <a:latin typeface="Calibri" pitchFamily="34" charset="0"/>
+                    <a:ea typeface="Calibri" pitchFamily="34" charset="-122"/>
+                    <a:cs typeface="Calibri" pitchFamily="34" charset="-120"/>
+                  </a:rPr>
+                  <a:t>(median of distribution per EDA)</a:t>
+                </a:r>
+                <a:endParaRPr lang="en-US" sz="900" dirty="0"/>
+              </a:p>
+            </p:txBody>
+          </p:sp>
+        </p:grpSp>
+      </p:grpSp>
     </p:spTree>
   </p:cSld>
   <p:clrMapOvr>
@@ -4686,6 +4758,13 @@
           </a:solidFill>
           <a:ln/>
         </p:spPr>
+        <p:txBody>
+          <a:bodyPr/>
+          <a:lstStyle/>
+          <a:p>
+            <a:endParaRPr lang="en-US"/>
+          </a:p>
+        </p:txBody>
       </p:sp>
       <p:sp>
         <p:nvSpPr>
@@ -4706,6 +4785,13 @@
           </a:solidFill>
           <a:ln/>
         </p:spPr>
+        <p:txBody>
+          <a:bodyPr/>
+          <a:lstStyle/>
+          <a:p>
+            <a:endParaRPr lang="en-US"/>
+          </a:p>
+        </p:txBody>
       </p:sp>
       <p:sp>
         <p:nvSpPr>
@@ -4728,11 +4814,11 @@
           <a:bodyPr wrap="square" rtlCol="0" anchor="ctr"/>
           <a:lstStyle/>
           <a:p>
-            <a:pPr indent="0" marL="0">
-              <a:buNone/>
-            </a:pPr>
-            <a:r>
-              <a:rPr lang="en-US" sz="800" b="1" spc="300" kern="0" dirty="0">
+            <a:pPr marL="0" indent="0">
+              <a:buNone/>
+            </a:pPr>
+            <a:r>
+              <a:rPr lang="en-US" sz="800" b="1" kern="0" spc="300" dirty="0">
                 <a:solidFill>
                   <a:srgbClr val="F4A261"/>
                 </a:solidFill>
@@ -4767,7 +4853,7 @@
           <a:bodyPr wrap="square" rtlCol="0" anchor="ctr"/>
           <a:lstStyle/>
           <a:p>
-            <a:pPr indent="0" marL="0">
+            <a:pPr marL="0" indent="0">
               <a:buNone/>
             </a:pPr>
             <a:r>
@@ -4811,6 +4897,13 @@
             <a:prstDash val="solid"/>
           </a:ln>
         </p:spPr>
+        <p:txBody>
+          <a:bodyPr/>
+          <a:lstStyle/>
+          <a:p>
+            <a:endParaRPr lang="en-US"/>
+          </a:p>
+        </p:txBody>
       </p:sp>
       <p:sp>
         <p:nvSpPr>
@@ -4833,6 +4926,13 @@
           </a:solidFill>
           <a:ln/>
         </p:spPr>
+        <p:txBody>
+          <a:bodyPr/>
+          <a:lstStyle/>
+          <a:p>
+            <a:endParaRPr lang="en-US"/>
+          </a:p>
+        </p:txBody>
       </p:sp>
       <p:sp>
         <p:nvSpPr>
@@ -4855,7 +4955,7 @@
           <a:bodyPr wrap="square" lIns="0" tIns="0" rIns="0" bIns="0" rtlCol="0" anchor="ctr"/>
           <a:lstStyle/>
           <a:p>
-            <a:pPr algn="ctr" indent="0" marL="0">
+            <a:pPr marL="0" indent="0" algn="ctr">
               <a:buNone/>
             </a:pPr>
             <a:r>
@@ -4894,7 +4994,7 @@
           <a:bodyPr wrap="square" rtlCol="0" anchor="ctr"/>
           <a:lstStyle/>
           <a:p>
-            <a:pPr indent="0" marL="0">
+            <a:pPr marL="0" indent="0">
               <a:buNone/>
             </a:pPr>
             <a:r>
@@ -4933,7 +5033,7 @@
           <a:bodyPr wrap="square" rtlCol="0" anchor="ctr"/>
           <a:lstStyle/>
           <a:p>
-            <a:pPr indent="0" marL="0">
+            <a:pPr marL="0" indent="0">
               <a:buNone/>
             </a:pPr>
             <a:r>
@@ -4972,7 +5072,7 @@
           <a:bodyPr wrap="square" rtlCol="0" anchor="ctr"/>
           <a:lstStyle/>
           <a:p>
-            <a:pPr indent="0" marL="0">
+            <a:pPr marL="0" indent="0">
               <a:buNone/>
             </a:pPr>
             <a:r>
@@ -5011,7 +5111,7 @@
           <a:bodyPr wrap="square" rtlCol="0" anchor="ctr"/>
           <a:lstStyle/>
           <a:p>
-            <a:pPr indent="0" marL="0">
+            <a:pPr marL="0" indent="0">
               <a:buNone/>
             </a:pPr>
             <a:r>
@@ -5050,7 +5150,7 @@
           <a:bodyPr wrap="square" rtlCol="0" anchor="ctr"/>
           <a:lstStyle/>
           <a:p>
-            <a:pPr indent="0" marL="0">
+            <a:pPr marL="0" indent="0">
               <a:buNone/>
             </a:pPr>
             <a:r>
@@ -5094,6 +5194,13 @@
             <a:prstDash val="solid"/>
           </a:ln>
         </p:spPr>
+        <p:txBody>
+          <a:bodyPr/>
+          <a:lstStyle/>
+          <a:p>
+            <a:endParaRPr lang="en-US"/>
+          </a:p>
+        </p:txBody>
       </p:sp>
       <p:sp>
         <p:nvSpPr>
@@ -5116,6 +5223,13 @@
           </a:solidFill>
           <a:ln/>
         </p:spPr>
+        <p:txBody>
+          <a:bodyPr/>
+          <a:lstStyle/>
+          <a:p>
+            <a:endParaRPr lang="en-US"/>
+          </a:p>
+        </p:txBody>
       </p:sp>
       <p:sp>
         <p:nvSpPr>
@@ -5138,7 +5252,7 @@
           <a:bodyPr wrap="square" lIns="0" tIns="0" rIns="0" bIns="0" rtlCol="0" anchor="ctr"/>
           <a:lstStyle/>
           <a:p>
-            <a:pPr algn="ctr" indent="0" marL="0">
+            <a:pPr marL="0" indent="0" algn="ctr">
               <a:buNone/>
             </a:pPr>
             <a:r>
@@ -5177,7 +5291,7 @@
           <a:bodyPr wrap="square" rtlCol="0" anchor="ctr"/>
           <a:lstStyle/>
           <a:p>
-            <a:pPr indent="0" marL="0">
+            <a:pPr marL="0" indent="0">
               <a:buNone/>
             </a:pPr>
             <a:r>
@@ -5216,7 +5330,7 @@
           <a:bodyPr wrap="square" rtlCol="0" anchor="ctr"/>
           <a:lstStyle/>
           <a:p>
-            <a:pPr indent="0" marL="0">
+            <a:pPr marL="0" indent="0">
               <a:buNone/>
             </a:pPr>
             <a:r>
@@ -5255,7 +5369,7 @@
           <a:bodyPr wrap="square" rtlCol="0" anchor="ctr"/>
           <a:lstStyle/>
           <a:p>
-            <a:pPr indent="0" marL="0">
+            <a:pPr marL="0" indent="0">
               <a:buNone/>
             </a:pPr>
             <a:r>
@@ -5294,7 +5408,7 @@
           <a:bodyPr wrap="square" rtlCol="0" anchor="ctr"/>
           <a:lstStyle/>
           <a:p>
-            <a:pPr indent="0" marL="0">
+            <a:pPr marL="0" indent="0">
               <a:buNone/>
             </a:pPr>
             <a:r>
@@ -5333,7 +5447,7 @@
           <a:bodyPr wrap="square" rtlCol="0" anchor="ctr"/>
           <a:lstStyle/>
           <a:p>
-            <a:pPr indent="0" marL="0">
+            <a:pPr marL="0" indent="0">
               <a:buNone/>
             </a:pPr>
             <a:r>
@@ -5377,6 +5491,13 @@
             <a:prstDash val="solid"/>
           </a:ln>
         </p:spPr>
+        <p:txBody>
+          <a:bodyPr/>
+          <a:lstStyle/>
+          <a:p>
+            <a:endParaRPr lang="en-US"/>
+          </a:p>
+        </p:txBody>
       </p:sp>
       <p:sp>
         <p:nvSpPr>
@@ -5399,6 +5520,13 @@
           </a:solidFill>
           <a:ln/>
         </p:spPr>
+        <p:txBody>
+          <a:bodyPr/>
+          <a:lstStyle/>
+          <a:p>
+            <a:endParaRPr lang="en-US"/>
+          </a:p>
+        </p:txBody>
       </p:sp>
       <p:sp>
         <p:nvSpPr>
@@ -5421,7 +5549,7 @@
           <a:bodyPr wrap="square" lIns="0" tIns="0" rIns="0" bIns="0" rtlCol="0" anchor="ctr"/>
           <a:lstStyle/>
           <a:p>
-            <a:pPr algn="ctr" indent="0" marL="0">
+            <a:pPr marL="0" indent="0" algn="ctr">
               <a:buNone/>
             </a:pPr>
             <a:r>
@@ -5460,7 +5588,7 @@
           <a:bodyPr wrap="square" rtlCol="0" anchor="ctr"/>
           <a:lstStyle/>
           <a:p>
-            <a:pPr indent="0" marL="0">
+            <a:pPr marL="0" indent="0">
               <a:buNone/>
             </a:pPr>
             <a:r>
@@ -5499,7 +5627,7 @@
           <a:bodyPr wrap="square" rtlCol="0" anchor="ctr"/>
           <a:lstStyle/>
           <a:p>
-            <a:pPr indent="0" marL="0">
+            <a:pPr marL="0" indent="0">
               <a:buNone/>
             </a:pPr>
             <a:r>
@@ -5538,7 +5666,7 @@
           <a:bodyPr wrap="square" rtlCol="0" anchor="ctr"/>
           <a:lstStyle/>
           <a:p>
-            <a:pPr indent="0" marL="0">
+            <a:pPr marL="0" indent="0">
               <a:buNone/>
             </a:pPr>
             <a:r>
@@ -5577,7 +5705,7 @@
           <a:bodyPr wrap="square" rtlCol="0" anchor="ctr"/>
           <a:lstStyle/>
           <a:p>
-            <a:pPr indent="0" marL="0">
+            <a:pPr marL="0" indent="0">
               <a:buNone/>
             </a:pPr>
             <a:r>
@@ -5616,7 +5744,7 @@
           <a:bodyPr wrap="square" rtlCol="0" anchor="ctr"/>
           <a:lstStyle/>
           <a:p>
-            <a:pPr indent="0" marL="0">
+            <a:pPr marL="0" indent="0">
               <a:buNone/>
             </a:pPr>
             <a:r>
@@ -5678,6 +5806,13 @@
           </a:solidFill>
           <a:ln/>
         </p:spPr>
+        <p:txBody>
+          <a:bodyPr/>
+          <a:lstStyle/>
+          <a:p>
+            <a:endParaRPr lang="en-US"/>
+          </a:p>
+        </p:txBody>
       </p:sp>
       <p:sp>
         <p:nvSpPr>
@@ -5698,6 +5833,13 @@
           </a:solidFill>
           <a:ln/>
         </p:spPr>
+        <p:txBody>
+          <a:bodyPr/>
+          <a:lstStyle/>
+          <a:p>
+            <a:endParaRPr lang="en-US"/>
+          </a:p>
+        </p:txBody>
       </p:sp>
       <p:sp>
         <p:nvSpPr>
@@ -5718,6 +5860,13 @@
           </a:solidFill>
           <a:ln/>
         </p:spPr>
+        <p:txBody>
+          <a:bodyPr/>
+          <a:lstStyle/>
+          <a:p>
+            <a:endParaRPr lang="en-US"/>
+          </a:p>
+        </p:txBody>
       </p:sp>
       <p:sp>
         <p:nvSpPr>
@@ -5740,11 +5889,11 @@
           <a:bodyPr wrap="square" rtlCol="0" anchor="ctr"/>
           <a:lstStyle/>
           <a:p>
-            <a:pPr indent="0" marL="0">
-              <a:buNone/>
-            </a:pPr>
-            <a:r>
-              <a:rPr lang="en-US" sz="800" b="1" spc="300" kern="0" dirty="0">
+            <a:pPr marL="0" indent="0">
+              <a:buNone/>
+            </a:pPr>
+            <a:r>
+              <a:rPr lang="en-US" sz="800" b="1" kern="0" spc="300" dirty="0">
                 <a:solidFill>
                   <a:srgbClr val="F4A261"/>
                 </a:solidFill>
@@ -5779,7 +5928,7 @@
           <a:bodyPr wrap="square" rtlCol="0" anchor="ctr"/>
           <a:lstStyle/>
           <a:p>
-            <a:pPr indent="0" marL="0">
+            <a:pPr marL="0" indent="0">
               <a:buNone/>
             </a:pPr>
             <a:r>
@@ -5818,6 +5967,13 @@
           </a:solidFill>
           <a:ln/>
         </p:spPr>
+        <p:txBody>
+          <a:bodyPr/>
+          <a:lstStyle/>
+          <a:p>
+            <a:endParaRPr lang="en-US"/>
+          </a:p>
+        </p:txBody>
       </p:sp>
       <p:sp>
         <p:nvSpPr>
@@ -5840,7 +5996,7 @@
           <a:bodyPr wrap="square" rtlCol="0" anchor="ctr"/>
           <a:lstStyle/>
           <a:p>
-            <a:pPr algn="ctr" indent="0" marL="0">
+            <a:pPr marL="0" indent="0" algn="ctr">
               <a:buNone/>
             </a:pPr>
             <a:r>
@@ -5879,7 +6035,7 @@
           <a:bodyPr wrap="square" rtlCol="0" anchor="ctr"/>
           <a:lstStyle/>
           <a:p>
-            <a:pPr algn="ctr" indent="0" marL="0">
+            <a:pPr marL="0" indent="0" algn="ctr">
               <a:buNone/>
             </a:pPr>
             <a:r>
@@ -5918,7 +6074,7 @@
           <a:bodyPr wrap="square" rtlCol="0" anchor="ctr"/>
           <a:lstStyle/>
           <a:p>
-            <a:pPr algn="ctr" indent="0" marL="0">
+            <a:pPr marL="0" indent="0" algn="ctr">
               <a:buNone/>
             </a:pPr>
             <a:r>
@@ -5957,6 +6113,13 @@
           </a:solidFill>
           <a:ln/>
         </p:spPr>
+        <p:txBody>
+          <a:bodyPr/>
+          <a:lstStyle/>
+          <a:p>
+            <a:endParaRPr lang="en-US"/>
+          </a:p>
+        </p:txBody>
       </p:sp>
       <p:sp>
         <p:nvSpPr>
@@ -5979,7 +6142,7 @@
           <a:bodyPr wrap="square" rtlCol="0" anchor="ctr"/>
           <a:lstStyle/>
           <a:p>
-            <a:pPr algn="ctr" indent="0" marL="0">
+            <a:pPr marL="0" indent="0" algn="ctr">
               <a:buNone/>
             </a:pPr>
             <a:r>
@@ -6018,7 +6181,7 @@
           <a:bodyPr wrap="square" rtlCol="0" anchor="ctr"/>
           <a:lstStyle/>
           <a:p>
-            <a:pPr algn="ctr" indent="0" marL="0">
+            <a:pPr marL="0" indent="0" algn="ctr">
               <a:buNone/>
             </a:pPr>
             <a:r>
@@ -6057,7 +6220,7 @@
           <a:bodyPr wrap="square" rtlCol="0" anchor="ctr"/>
           <a:lstStyle/>
           <a:p>
-            <a:pPr algn="ctr" indent="0" marL="0">
+            <a:pPr marL="0" indent="0" algn="ctr">
               <a:buNone/>
             </a:pPr>
             <a:r>
@@ -6096,6 +6259,13 @@
           </a:solidFill>
           <a:ln/>
         </p:spPr>
+        <p:txBody>
+          <a:bodyPr/>
+          <a:lstStyle/>
+          <a:p>
+            <a:endParaRPr lang="en-US"/>
+          </a:p>
+        </p:txBody>
       </p:sp>
       <p:sp>
         <p:nvSpPr>
@@ -6118,7 +6288,7 @@
           <a:bodyPr wrap="square" rtlCol="0" anchor="ctr"/>
           <a:lstStyle/>
           <a:p>
-            <a:pPr algn="ctr" indent="0" marL="0">
+            <a:pPr marL="0" indent="0" algn="ctr">
               <a:buNone/>
             </a:pPr>
             <a:r>
@@ -6157,7 +6327,7 @@
           <a:bodyPr wrap="square" rtlCol="0" anchor="ctr"/>
           <a:lstStyle/>
           <a:p>
-            <a:pPr algn="ctr" indent="0" marL="0">
+            <a:pPr marL="0" indent="0" algn="ctr">
               <a:buNone/>
             </a:pPr>
             <a:r>
@@ -6196,7 +6366,7 @@
           <a:bodyPr wrap="square" rtlCol="0" anchor="ctr"/>
           <a:lstStyle/>
           <a:p>
-            <a:pPr algn="ctr" indent="0" marL="0">
+            <a:pPr marL="0" indent="0" algn="ctr">
               <a:buNone/>
             </a:pPr>
             <a:r>
@@ -6235,6 +6405,13 @@
           </a:solidFill>
           <a:ln/>
         </p:spPr>
+        <p:txBody>
+          <a:bodyPr/>
+          <a:lstStyle/>
+          <a:p>
+            <a:endParaRPr lang="en-US"/>
+          </a:p>
+        </p:txBody>
       </p:sp>
       <p:sp>
         <p:nvSpPr>
@@ -6257,7 +6434,7 @@
           <a:bodyPr wrap="square" rtlCol="0" anchor="ctr"/>
           <a:lstStyle/>
           <a:p>
-            <a:pPr algn="ctr" indent="0" marL="0">
+            <a:pPr marL="0" indent="0" algn="ctr">
               <a:buNone/>
             </a:pPr>
             <a:r>
@@ -6296,7 +6473,7 @@
           <a:bodyPr wrap="square" rtlCol="0" anchor="ctr"/>
           <a:lstStyle/>
           <a:p>
-            <a:pPr algn="ctr" indent="0" marL="0">
+            <a:pPr marL="0" indent="0" algn="ctr">
               <a:buNone/>
             </a:pPr>
             <a:r>
@@ -6335,7 +6512,7 @@
           <a:bodyPr wrap="square" rtlCol="0" anchor="ctr"/>
           <a:lstStyle/>
           <a:p>
-            <a:pPr algn="ctr" indent="0" marL="0">
+            <a:pPr marL="0" indent="0" algn="ctr">
               <a:buNone/>
             </a:pPr>
             <a:r>
@@ -6374,6 +6551,13 @@
           </a:solidFill>
           <a:ln/>
         </p:spPr>
+        <p:txBody>
+          <a:bodyPr/>
+          <a:lstStyle/>
+          <a:p>
+            <a:endParaRPr lang="en-US"/>
+          </a:p>
+        </p:txBody>
       </p:sp>
       <p:sp>
         <p:nvSpPr>
@@ -6396,7 +6580,7 @@
           <a:bodyPr wrap="square" rtlCol="0" anchor="ctr"/>
           <a:lstStyle/>
           <a:p>
-            <a:pPr indent="0" marL="0">
+            <a:pPr marL="0" indent="0">
               <a:buNone/>
             </a:pPr>
             <a:r>
@@ -6435,7 +6619,7 @@
           <a:bodyPr wrap="square" rtlCol="0" anchor="ctr"/>
           <a:lstStyle/>
           <a:p>
-            <a:pPr indent="0" marL="0">
+            <a:pPr marL="0" indent="0">
               <a:buNone/>
             </a:pPr>
             <a:r>
@@ -6474,7 +6658,7 @@
           <a:bodyPr wrap="square" rtlCol="0" anchor="ctr"/>
           <a:lstStyle/>
           <a:p>
-            <a:pPr indent="0" marL="0">
+            <a:pPr marL="0" indent="0">
               <a:buNone/>
             </a:pPr>
             <a:r>
@@ -6513,6 +6697,13 @@
           </a:solidFill>
           <a:ln/>
         </p:spPr>
+        <p:txBody>
+          <a:bodyPr/>
+          <a:lstStyle/>
+          <a:p>
+            <a:endParaRPr lang="en-US"/>
+          </a:p>
+        </p:txBody>
       </p:sp>
       <p:sp>
         <p:nvSpPr>
@@ -6535,7 +6726,7 @@
           <a:bodyPr wrap="square" rtlCol="0" anchor="ctr"/>
           <a:lstStyle/>
           <a:p>
-            <a:pPr indent="0" marL="0">
+            <a:pPr marL="0" indent="0">
               <a:buNone/>
             </a:pPr>
             <a:r>
@@ -6574,7 +6765,7 @@
           <a:bodyPr wrap="square" rtlCol="0" anchor="ctr"/>
           <a:lstStyle/>
           <a:p>
-            <a:pPr indent="0" marL="0">
+            <a:pPr marL="0" indent="0">
               <a:buNone/>
             </a:pPr>
             <a:r>
@@ -6613,7 +6804,7 @@
           <a:bodyPr wrap="square" rtlCol="0" anchor="ctr"/>
           <a:lstStyle/>
           <a:p>
-            <a:pPr indent="0" marL="0">
+            <a:pPr marL="0" indent="0">
               <a:buNone/>
             </a:pPr>
             <a:r>
@@ -6652,6 +6843,13 @@
           </a:solidFill>
           <a:ln/>
         </p:spPr>
+        <p:txBody>
+          <a:bodyPr/>
+          <a:lstStyle/>
+          <a:p>
+            <a:endParaRPr lang="en-US"/>
+          </a:p>
+        </p:txBody>
       </p:sp>
       <p:sp>
         <p:nvSpPr>
@@ -6674,7 +6872,7 @@
           <a:bodyPr wrap="square" rtlCol="0" anchor="ctr"/>
           <a:lstStyle/>
           <a:p>
-            <a:pPr indent="0" marL="0">
+            <a:pPr marL="0" indent="0">
               <a:buNone/>
             </a:pPr>
             <a:r>
@@ -6713,7 +6911,7 @@
           <a:bodyPr wrap="square" rtlCol="0" anchor="ctr"/>
           <a:lstStyle/>
           <a:p>
-            <a:pPr indent="0" marL="0">
+            <a:pPr marL="0" indent="0">
               <a:buNone/>
             </a:pPr>
             <a:r>
@@ -6752,7 +6950,7 @@
           <a:bodyPr wrap="square" rtlCol="0" anchor="ctr"/>
           <a:lstStyle/>
           <a:p>
-            <a:pPr indent="0" marL="0">
+            <a:pPr marL="0" indent="0">
               <a:buNone/>
             </a:pPr>
             <a:r>
@@ -6814,6 +7012,13 @@
           </a:solidFill>
           <a:ln/>
         </p:spPr>
+        <p:txBody>
+          <a:bodyPr/>
+          <a:lstStyle/>
+          <a:p>
+            <a:endParaRPr lang="en-US"/>
+          </a:p>
+        </p:txBody>
       </p:sp>
       <p:sp>
         <p:nvSpPr>
@@ -6836,11 +7041,11 @@
           <a:bodyPr wrap="square" rtlCol="0" anchor="ctr"/>
           <a:lstStyle/>
           <a:p>
-            <a:pPr indent="0" marL="0">
-              <a:buNone/>
-            </a:pPr>
-            <a:r>
-              <a:rPr lang="en-US" sz="800" b="1" spc="300" kern="0" dirty="0">
+            <a:pPr marL="0" indent="0">
+              <a:buNone/>
+            </a:pPr>
+            <a:r>
+              <a:rPr lang="en-US" sz="800" b="1" kern="0" spc="300" dirty="0">
                 <a:solidFill>
                   <a:srgbClr val="0D4C6B"/>
                 </a:solidFill>
@@ -6875,7 +7080,7 @@
           <a:bodyPr wrap="square" rtlCol="0" anchor="ctr"/>
           <a:lstStyle/>
           <a:p>
-            <a:pPr indent="0" marL="0">
+            <a:pPr marL="0" indent="0">
               <a:buNone/>
             </a:pPr>
             <a:r>
@@ -6914,6 +7119,13 @@
           </a:solidFill>
           <a:ln/>
         </p:spPr>
+        <p:txBody>
+          <a:bodyPr/>
+          <a:lstStyle/>
+          <a:p>
+            <a:endParaRPr lang="en-US"/>
+          </a:p>
+        </p:txBody>
       </p:sp>
       <p:sp>
         <p:nvSpPr>
@@ -6936,7 +7148,7 @@
           <a:bodyPr wrap="square" rtlCol="0" anchor="ctr"/>
           <a:lstStyle/>
           <a:p>
-            <a:pPr algn="ctr" indent="0" marL="0">
+            <a:pPr marL="0" indent="0" algn="ctr">
               <a:buNone/>
             </a:pPr>
             <a:r>
@@ -6975,7 +7187,7 @@
           <a:bodyPr wrap="square" rtlCol="0" anchor="ctr"/>
           <a:lstStyle/>
           <a:p>
-            <a:pPr algn="ctr" indent="0" marL="0">
+            <a:pPr marL="0" indent="0" algn="ctr">
               <a:buNone/>
             </a:pPr>
             <a:r>
@@ -7014,7 +7226,7 @@
           <a:bodyPr wrap="square" rtlCol="0" anchor="ctr"/>
           <a:lstStyle/>
           <a:p>
-            <a:pPr algn="ctr" indent="0" marL="0">
+            <a:pPr marL="0" indent="0" algn="ctr">
               <a:buNone/>
             </a:pPr>
             <a:r>
@@ -7053,7 +7265,7 @@
           <a:bodyPr wrap="square" rtlCol="0" anchor="ctr"/>
           <a:lstStyle/>
           <a:p>
-            <a:pPr algn="ctr" indent="0" marL="0">
+            <a:pPr marL="0" indent="0" algn="ctr">
               <a:buNone/>
             </a:pPr>
             <a:r>
@@ -7092,6 +7304,13 @@
           </a:solidFill>
           <a:ln/>
         </p:spPr>
+        <p:txBody>
+          <a:bodyPr/>
+          <a:lstStyle/>
+          <a:p>
+            <a:endParaRPr lang="en-US"/>
+          </a:p>
+        </p:txBody>
       </p:sp>
       <p:sp>
         <p:nvSpPr>
@@ -7114,7 +7333,7 @@
           <a:bodyPr wrap="square" rtlCol="0" anchor="ctr"/>
           <a:lstStyle/>
           <a:p>
-            <a:pPr algn="ctr" indent="0" marL="0">
+            <a:pPr marL="0" indent="0" algn="ctr">
               <a:buNone/>
             </a:pPr>
             <a:r>
@@ -7153,7 +7372,7 @@
           <a:bodyPr wrap="square" rtlCol="0" anchor="ctr"/>
           <a:lstStyle/>
           <a:p>
-            <a:pPr algn="ctr" indent="0" marL="0">
+            <a:pPr marL="0" indent="0" algn="ctr">
               <a:buNone/>
             </a:pPr>
             <a:r>
@@ -7192,7 +7411,7 @@
           <a:bodyPr wrap="square" rtlCol="0" anchor="ctr"/>
           <a:lstStyle/>
           <a:p>
-            <a:pPr algn="ctr" indent="0" marL="0">
+            <a:pPr marL="0" indent="0" algn="ctr">
               <a:buNone/>
             </a:pPr>
             <a:r>
@@ -7231,7 +7450,7 @@
           <a:bodyPr wrap="square" rtlCol="0" anchor="ctr"/>
           <a:lstStyle/>
           <a:p>
-            <a:pPr algn="ctr" indent="0" marL="0">
+            <a:pPr marL="0" indent="0" algn="ctr">
               <a:buNone/>
             </a:pPr>
             <a:r>
@@ -7270,6 +7489,13 @@
           </a:solidFill>
           <a:ln/>
         </p:spPr>
+        <p:txBody>
+          <a:bodyPr/>
+          <a:lstStyle/>
+          <a:p>
+            <a:endParaRPr lang="en-US"/>
+          </a:p>
+        </p:txBody>
       </p:sp>
       <p:sp>
         <p:nvSpPr>
@@ -7292,7 +7518,7 @@
           <a:bodyPr wrap="square" rtlCol="0" anchor="ctr"/>
           <a:lstStyle/>
           <a:p>
-            <a:pPr algn="ctr" indent="0" marL="0">
+            <a:pPr marL="0" indent="0" algn="ctr">
               <a:buNone/>
             </a:pPr>
             <a:r>
@@ -7331,7 +7557,7 @@
           <a:bodyPr wrap="square" rtlCol="0" anchor="ctr"/>
           <a:lstStyle/>
           <a:p>
-            <a:pPr algn="ctr" indent="0" marL="0">
+            <a:pPr marL="0" indent="0" algn="ctr">
               <a:buNone/>
             </a:pPr>
             <a:r>
@@ -7370,7 +7596,7 @@
           <a:bodyPr wrap="square" rtlCol="0" anchor="ctr"/>
           <a:lstStyle/>
           <a:p>
-            <a:pPr algn="ctr" indent="0" marL="0">
+            <a:pPr marL="0" indent="0" algn="ctr">
               <a:buNone/>
             </a:pPr>
             <a:r>
@@ -7409,7 +7635,7 @@
           <a:bodyPr wrap="square" rtlCol="0" anchor="ctr"/>
           <a:lstStyle/>
           <a:p>
-            <a:pPr algn="ctr" indent="0" marL="0">
+            <a:pPr marL="0" indent="0" algn="ctr">
               <a:buNone/>
             </a:pPr>
             <a:r>
@@ -7448,6 +7674,13 @@
           </a:solidFill>
           <a:ln/>
         </p:spPr>
+        <p:txBody>
+          <a:bodyPr/>
+          <a:lstStyle/>
+          <a:p>
+            <a:endParaRPr lang="en-US"/>
+          </a:p>
+        </p:txBody>
       </p:sp>
       <p:sp>
         <p:nvSpPr>
@@ -7470,7 +7703,7 @@
           <a:bodyPr wrap="square" rtlCol="0" anchor="ctr"/>
           <a:lstStyle/>
           <a:p>
-            <a:pPr algn="ctr" indent="0" marL="0">
+            <a:pPr marL="0" indent="0" algn="ctr">
               <a:buNone/>
             </a:pPr>
             <a:r>
@@ -7509,7 +7742,7 @@
           <a:bodyPr wrap="square" rtlCol="0" anchor="ctr"/>
           <a:lstStyle/>
           <a:p>
-            <a:pPr algn="ctr" indent="0" marL="0">
+            <a:pPr marL="0" indent="0" algn="ctr">
               <a:buNone/>
             </a:pPr>
             <a:r>
@@ -7548,7 +7781,7 @@
           <a:bodyPr wrap="square" rtlCol="0" anchor="ctr"/>
           <a:lstStyle/>
           <a:p>
-            <a:pPr algn="ctr" indent="0" marL="0">
+            <a:pPr marL="0" indent="0" algn="ctr">
               <a:buNone/>
             </a:pPr>
             <a:r>
@@ -7587,7 +7820,7 @@
           <a:bodyPr wrap="square" rtlCol="0" anchor="ctr"/>
           <a:lstStyle/>
           <a:p>
-            <a:pPr algn="ctr" indent="0" marL="0">
+            <a:pPr marL="0" indent="0" algn="ctr">
               <a:buNone/>
             </a:pPr>
             <a:r>
@@ -7626,6 +7859,13 @@
           </a:solidFill>
           <a:ln/>
         </p:spPr>
+        <p:txBody>
+          <a:bodyPr/>
+          <a:lstStyle/>
+          <a:p>
+            <a:endParaRPr lang="en-US"/>
+          </a:p>
+        </p:txBody>
       </p:sp>
       <p:sp>
         <p:nvSpPr>
@@ -7648,7 +7888,7 @@
           <a:bodyPr wrap="square" rtlCol="0" anchor="ctr"/>
           <a:lstStyle/>
           <a:p>
-            <a:pPr indent="0" marL="0">
+            <a:pPr marL="0" indent="0">
               <a:buNone/>
             </a:pPr>
             <a:r>
@@ -7687,7 +7927,7 @@
           <a:bodyPr wrap="square" rtlCol="0" anchor="ctr"/>
           <a:lstStyle/>
           <a:p>
-            <a:pPr indent="0" marL="0">
+            <a:pPr marL="0" indent="0">
               <a:buNone/>
             </a:pPr>
             <a:r>
@@ -7726,7 +7966,7 @@
           <a:bodyPr wrap="square" rtlCol="0" anchor="ctr"/>
           <a:lstStyle/>
           <a:p>
-            <a:pPr indent="0" marL="0">
+            <a:pPr marL="0" indent="0">
               <a:buNone/>
             </a:pPr>
             <a:r>
@@ -7788,6 +8028,13 @@
           </a:solidFill>
           <a:ln/>
         </p:spPr>
+        <p:txBody>
+          <a:bodyPr/>
+          <a:lstStyle/>
+          <a:p>
+            <a:endParaRPr lang="en-US"/>
+          </a:p>
+        </p:txBody>
       </p:sp>
       <p:sp>
         <p:nvSpPr>
@@ -7808,6 +8055,13 @@
           </a:solidFill>
           <a:ln/>
         </p:spPr>
+        <p:txBody>
+          <a:bodyPr/>
+          <a:lstStyle/>
+          <a:p>
+            <a:endParaRPr lang="en-US"/>
+          </a:p>
+        </p:txBody>
       </p:sp>
       <p:sp>
         <p:nvSpPr>
@@ -7828,6 +8082,13 @@
           </a:solidFill>
           <a:ln/>
         </p:spPr>
+        <p:txBody>
+          <a:bodyPr/>
+          <a:lstStyle/>
+          <a:p>
+            <a:endParaRPr lang="en-US"/>
+          </a:p>
+        </p:txBody>
       </p:sp>
       <p:sp>
         <p:nvSpPr>
@@ -7850,11 +8111,11 @@
           <a:bodyPr wrap="square" rtlCol="0" anchor="ctr"/>
           <a:lstStyle/>
           <a:p>
-            <a:pPr indent="0" marL="0">
-              <a:buNone/>
-            </a:pPr>
-            <a:r>
-              <a:rPr lang="en-US" sz="800" b="1" spc="300" kern="0" dirty="0">
+            <a:pPr marL="0" indent="0">
+              <a:buNone/>
+            </a:pPr>
+            <a:r>
+              <a:rPr lang="en-US" sz="800" b="1" kern="0" spc="300" dirty="0">
                 <a:solidFill>
                   <a:srgbClr val="F4A261"/>
                 </a:solidFill>
@@ -7889,7 +8150,7 @@
           <a:bodyPr wrap="square" rtlCol="0" anchor="ctr"/>
           <a:lstStyle/>
           <a:p>
-            <a:pPr indent="0" marL="0">
+            <a:pPr marL="0" indent="0">
               <a:buNone/>
             </a:pPr>
             <a:r>
@@ -7906,7 +8167,7 @@
             <a:endParaRPr lang="en-US" sz="3600" dirty="0"/>
           </a:p>
           <a:p>
-            <a:pPr indent="0" marL="0">
+            <a:pPr marL="0" indent="0">
               <a:buNone/>
             </a:pPr>
             <a:r>
@@ -7945,7 +8206,7 @@
           <a:bodyPr wrap="square" rtlCol="0" anchor="ctr"/>
           <a:lstStyle/>
           <a:p>
-            <a:pPr indent="0" marL="0">
+            <a:pPr marL="0" indent="0">
               <a:buNone/>
             </a:pPr>
             <a:r>
@@ -7981,7 +8242,7 @@
           <a:bodyPr wrap="square" rtlCol="0" anchor="ctr"/>
           <a:lstStyle/>
           <a:p>
-            <a:pPr indent="0" marL="0">
+            <a:pPr marL="0" indent="0">
               <a:buNone/>
             </a:pPr>
             <a:r>
@@ -8020,7 +8281,7 @@
           <a:bodyPr wrap="square" rtlCol="0" anchor="ctr"/>
           <a:lstStyle/>
           <a:p>
-            <a:pPr indent="0" marL="0">
+            <a:pPr marL="0" indent="0">
               <a:buNone/>
             </a:pPr>
             <a:r>
@@ -8056,7 +8317,7 @@
           <a:bodyPr wrap="square" rtlCol="0" anchor="ctr"/>
           <a:lstStyle/>
           <a:p>
-            <a:pPr indent="0" marL="0">
+            <a:pPr marL="0" indent="0">
               <a:buNone/>
             </a:pPr>
             <a:r>
@@ -8095,7 +8356,7 @@
           <a:bodyPr wrap="square" rtlCol="0" anchor="ctr"/>
           <a:lstStyle/>
           <a:p>
-            <a:pPr indent="0" marL="0">
+            <a:pPr marL="0" indent="0">
               <a:buNone/>
             </a:pPr>
             <a:r>
@@ -8131,7 +8392,7 @@
           <a:bodyPr wrap="square" rtlCol="0" anchor="ctr"/>
           <a:lstStyle/>
           <a:p>
-            <a:pPr indent="0" marL="0">
+            <a:pPr marL="0" indent="0">
               <a:buNone/>
             </a:pPr>
             <a:r>
@@ -8170,7 +8431,7 @@
           <a:bodyPr wrap="square" rtlCol="0" anchor="ctr"/>
           <a:lstStyle/>
           <a:p>
-            <a:pPr indent="0" marL="0">
+            <a:pPr marL="0" indent="0">
               <a:buNone/>
             </a:pPr>
             <a:r>
@@ -8206,7 +8467,7 @@
           <a:bodyPr wrap="square" rtlCol="0" anchor="ctr"/>
           <a:lstStyle/>
           <a:p>
-            <a:pPr indent="0" marL="0">
+            <a:pPr marL="0" indent="0">
               <a:buNone/>
             </a:pPr>
             <a:r>
@@ -8268,6 +8529,13 @@
           </a:solidFill>
           <a:ln/>
         </p:spPr>
+        <p:txBody>
+          <a:bodyPr/>
+          <a:lstStyle/>
+          <a:p>
+            <a:endParaRPr lang="en-US"/>
+          </a:p>
+        </p:txBody>
       </p:sp>
       <p:sp>
         <p:nvSpPr>
@@ -8288,6 +8556,13 @@
           </a:solidFill>
           <a:ln/>
         </p:spPr>
+        <p:txBody>
+          <a:bodyPr/>
+          <a:lstStyle/>
+          <a:p>
+            <a:endParaRPr lang="en-US"/>
+          </a:p>
+        </p:txBody>
       </p:sp>
       <p:sp>
         <p:nvSpPr>
@@ -8310,7 +8585,7 @@
           <a:bodyPr wrap="square" rtlCol="0" anchor="ctr"/>
           <a:lstStyle/>
           <a:p>
-            <a:pPr indent="0" marL="0">
+            <a:pPr marL="0" indent="0">
               <a:buNone/>
             </a:pPr>
             <a:r>
@@ -8354,6 +8629,13 @@
             <a:prstDash val="solid"/>
           </a:ln>
         </p:spPr>
+        <p:txBody>
+          <a:bodyPr/>
+          <a:lstStyle/>
+          <a:p>
+            <a:endParaRPr lang="en-US"/>
+          </a:p>
+        </p:txBody>
       </p:sp>
       <p:sp>
         <p:nvSpPr>
@@ -8376,6 +8658,13 @@
           </a:solidFill>
           <a:ln/>
         </p:spPr>
+        <p:txBody>
+          <a:bodyPr/>
+          <a:lstStyle/>
+          <a:p>
+            <a:endParaRPr lang="en-US"/>
+          </a:p>
+        </p:txBody>
       </p:sp>
       <p:sp>
         <p:nvSpPr>
@@ -8398,7 +8687,7 @@
           <a:bodyPr wrap="square" rtlCol="0" anchor="ctr"/>
           <a:lstStyle/>
           <a:p>
-            <a:pPr indent="0" marL="0">
+            <a:pPr marL="0" indent="0">
               <a:buNone/>
             </a:pPr>
             <a:r>
@@ -8437,7 +8726,7 @@
           <a:bodyPr wrap="square" rtlCol="0" anchor="ctr"/>
           <a:lstStyle/>
           <a:p>
-            <a:pPr indent="0" marL="0">
+            <a:pPr marL="0" indent="0">
               <a:buNone/>
             </a:pPr>
             <a:r>
@@ -8481,6 +8770,13 @@
             <a:prstDash val="solid"/>
           </a:ln>
         </p:spPr>
+        <p:txBody>
+          <a:bodyPr/>
+          <a:lstStyle/>
+          <a:p>
+            <a:endParaRPr lang="en-US"/>
+          </a:p>
+        </p:txBody>
       </p:sp>
       <p:sp>
         <p:nvSpPr>
@@ -8503,6 +8799,13 @@
           </a:solidFill>
           <a:ln/>
         </p:spPr>
+        <p:txBody>
+          <a:bodyPr/>
+          <a:lstStyle/>
+          <a:p>
+            <a:endParaRPr lang="en-US"/>
+          </a:p>
+        </p:txBody>
       </p:sp>
       <p:sp>
         <p:nvSpPr>
@@ -8525,7 +8828,7 @@
           <a:bodyPr wrap="square" rtlCol="0" anchor="ctr"/>
           <a:lstStyle/>
           <a:p>
-            <a:pPr indent="0" marL="0">
+            <a:pPr marL="0" indent="0">
               <a:buNone/>
             </a:pPr>
             <a:r>
@@ -8564,7 +8867,7 @@
           <a:bodyPr wrap="square" rtlCol="0" anchor="ctr"/>
           <a:lstStyle/>
           <a:p>
-            <a:pPr indent="0" marL="0">
+            <a:pPr marL="0" indent="0">
               <a:buNone/>
             </a:pPr>
             <a:r>
@@ -8608,6 +8911,13 @@
             <a:prstDash val="solid"/>
           </a:ln>
         </p:spPr>
+        <p:txBody>
+          <a:bodyPr/>
+          <a:lstStyle/>
+          <a:p>
+            <a:endParaRPr lang="en-US"/>
+          </a:p>
+        </p:txBody>
       </p:sp>
       <p:sp>
         <p:nvSpPr>
@@ -8630,6 +8940,13 @@
           </a:solidFill>
           <a:ln/>
         </p:spPr>
+        <p:txBody>
+          <a:bodyPr/>
+          <a:lstStyle/>
+          <a:p>
+            <a:endParaRPr lang="en-US"/>
+          </a:p>
+        </p:txBody>
       </p:sp>
       <p:sp>
         <p:nvSpPr>
@@ -8652,7 +8969,7 @@
           <a:bodyPr wrap="square" rtlCol="0" anchor="ctr"/>
           <a:lstStyle/>
           <a:p>
-            <a:pPr indent="0" marL="0">
+            <a:pPr marL="0" indent="0">
               <a:buNone/>
             </a:pPr>
             <a:r>
@@ -8691,7 +9008,7 @@
           <a:bodyPr wrap="square" rtlCol="0" anchor="ctr"/>
           <a:lstStyle/>
           <a:p>
-            <a:pPr indent="0" marL="0">
+            <a:pPr marL="0" indent="0">
               <a:buNone/>
             </a:pPr>
             <a:r>
@@ -8735,6 +9052,13 @@
             <a:prstDash val="solid"/>
           </a:ln>
         </p:spPr>
+        <p:txBody>
+          <a:bodyPr/>
+          <a:lstStyle/>
+          <a:p>
+            <a:endParaRPr lang="en-US"/>
+          </a:p>
+        </p:txBody>
       </p:sp>
       <p:sp>
         <p:nvSpPr>
@@ -8757,6 +9081,13 @@
           </a:solidFill>
           <a:ln/>
         </p:spPr>
+        <p:txBody>
+          <a:bodyPr/>
+          <a:lstStyle/>
+          <a:p>
+            <a:endParaRPr lang="en-US"/>
+          </a:p>
+        </p:txBody>
       </p:sp>
       <p:sp>
         <p:nvSpPr>
@@ -8779,7 +9110,7 @@
           <a:bodyPr wrap="square" rtlCol="0" anchor="ctr"/>
           <a:lstStyle/>
           <a:p>
-            <a:pPr indent="0" marL="0">
+            <a:pPr marL="0" indent="0">
               <a:buNone/>
             </a:pPr>
             <a:r>
@@ -8796,7 +9127,7 @@
             <a:endParaRPr lang="en-US" sz="1200" dirty="0"/>
           </a:p>
           <a:p>
-            <a:pPr indent="0" marL="0">
+            <a:pPr marL="0" indent="0">
               <a:buNone/>
             </a:pPr>
             <a:r>
@@ -8835,7 +9166,7 @@
           <a:bodyPr wrap="square" rtlCol="0" anchor="ctr"/>
           <a:lstStyle/>
           <a:p>
-            <a:pPr indent="0" marL="0">
+            <a:pPr marL="0" indent="0">
               <a:buNone/>
             </a:pPr>
             <a:r>
@@ -8879,6 +9210,13 @@
             <a:prstDash val="solid"/>
           </a:ln>
         </p:spPr>
+        <p:txBody>
+          <a:bodyPr/>
+          <a:lstStyle/>
+          <a:p>
+            <a:endParaRPr lang="en-US"/>
+          </a:p>
+        </p:txBody>
       </p:sp>
       <p:sp>
         <p:nvSpPr>
@@ -8901,6 +9239,13 @@
           </a:solidFill>
           <a:ln/>
         </p:spPr>
+        <p:txBody>
+          <a:bodyPr/>
+          <a:lstStyle/>
+          <a:p>
+            <a:endParaRPr lang="en-US"/>
+          </a:p>
+        </p:txBody>
       </p:sp>
       <p:sp>
         <p:nvSpPr>
@@ -8923,7 +9268,7 @@
           <a:bodyPr wrap="square" rtlCol="0" anchor="ctr"/>
           <a:lstStyle/>
           <a:p>
-            <a:pPr indent="0" marL="0">
+            <a:pPr marL="0" indent="0">
               <a:buNone/>
             </a:pPr>
             <a:r>
@@ -8962,7 +9307,7 @@
           <a:bodyPr wrap="square" rtlCol="0" anchor="ctr"/>
           <a:lstStyle/>
           <a:p>
-            <a:pPr indent="0" marL="0">
+            <a:pPr marL="0" indent="0">
               <a:buNone/>
             </a:pPr>
             <a:r>
@@ -9006,6 +9351,13 @@
             <a:prstDash val="solid"/>
           </a:ln>
         </p:spPr>
+        <p:txBody>
+          <a:bodyPr/>
+          <a:lstStyle/>
+          <a:p>
+            <a:endParaRPr lang="en-US"/>
+          </a:p>
+        </p:txBody>
       </p:sp>
       <p:sp>
         <p:nvSpPr>
@@ -9028,6 +9380,13 @@
           </a:solidFill>
           <a:ln/>
         </p:spPr>
+        <p:txBody>
+          <a:bodyPr/>
+          <a:lstStyle/>
+          <a:p>
+            <a:endParaRPr lang="en-US"/>
+          </a:p>
+        </p:txBody>
       </p:sp>
       <p:sp>
         <p:nvSpPr>
@@ -9050,7 +9409,7 @@
           <a:bodyPr wrap="square" rtlCol="0" anchor="ctr"/>
           <a:lstStyle/>
           <a:p>
-            <a:pPr indent="0" marL="0">
+            <a:pPr marL="0" indent="0">
               <a:buNone/>
             </a:pPr>
             <a:r>
@@ -9089,7 +9448,7 @@
           <a:bodyPr wrap="square" rtlCol="0" anchor="ctr"/>
           <a:lstStyle/>
           <a:p>
-            <a:pPr indent="0" marL="0">
+            <a:pPr marL="0" indent="0">
               <a:buNone/>
             </a:pPr>
             <a:r>
@@ -9128,6 +9487,13 @@
           </a:solidFill>
           <a:ln/>
         </p:spPr>
+        <p:txBody>
+          <a:bodyPr/>
+          <a:lstStyle/>
+          <a:p>
+            <a:endParaRPr lang="en-US"/>
+          </a:p>
+        </p:txBody>
       </p:sp>
       <p:sp>
         <p:nvSpPr>
@@ -9150,11 +9516,8 @@
           <a:bodyPr wrap="square" rtlCol="0" anchor="ctr"/>
           <a:lstStyle/>
           <a:p>
-            <a:pPr indent="0" marL="0">
-              <a:buNone/>
-            </a:pPr>
-            <a:r>
-              <a:rPr lang="en-US" sz="1100" dirty="0">
+            <a:r>
+              <a:rPr lang="en-US" sz="1100" b="1" dirty="0">
                 <a:solidFill>
                   <a:srgbClr val="F0F4F8"/>
                 </a:solidFill>
@@ -9162,7 +9525,52 @@
                 <a:ea typeface="Calibri" pitchFamily="34" charset="-122"/>
                 <a:cs typeface="Calibri" pitchFamily="34" charset="-120"/>
               </a:rPr>
-              <a:t>🔗  GitHub: github.com/rodriguesbrian/tt14_call_me_maybe_project     📊  Dashboard: Tableau Public — brian.rodrigues5391</a:t>
+              <a:t>GitHub:</a:t>
+            </a:r>
+            <a:r>
+              <a:rPr lang="en-US" sz="1100" dirty="0">
+                <a:solidFill>
+                  <a:srgbClr val="F0F4F8"/>
+                </a:solidFill>
+                <a:latin typeface="Calibri" pitchFamily="34" charset="0"/>
+                <a:ea typeface="Calibri" pitchFamily="34" charset="-122"/>
+                <a:cs typeface="Calibri" pitchFamily="34" charset="-120"/>
+              </a:rPr>
+              <a:t> github.com/rodriguesbrian/tt14_call_me_maybe_project </a:t>
+            </a:r>
+          </a:p>
+          <a:p>
+            <a:endParaRPr lang="en-US" sz="1100" dirty="0">
+              <a:solidFill>
+                <a:srgbClr val="F0F4F8"/>
+              </a:solidFill>
+              <a:latin typeface="Calibri" pitchFamily="34" charset="0"/>
+              <a:ea typeface="Calibri" pitchFamily="34" charset="-122"/>
+              <a:cs typeface="Calibri" pitchFamily="34" charset="-120"/>
+            </a:endParaRPr>
+          </a:p>
+          <a:p>
+            <a:r>
+              <a:rPr lang="en-US" sz="1100" b="1" dirty="0">
+                <a:solidFill>
+                  <a:srgbClr val="F0F4F8"/>
+                </a:solidFill>
+                <a:latin typeface="Calibri" pitchFamily="34" charset="0"/>
+                <a:ea typeface="Calibri" pitchFamily="34" charset="-122"/>
+                <a:cs typeface="Calibri" pitchFamily="34" charset="-120"/>
+              </a:rPr>
+              <a:t>Dashboard: Tableau Public </a:t>
+            </a:r>
+            <a:r>
+              <a:rPr lang="en-US" sz="1100" dirty="0">
+                <a:solidFill>
+                  <a:srgbClr val="F0F4F8"/>
+                </a:solidFill>
+                <a:latin typeface="Calibri" pitchFamily="34" charset="0"/>
+                <a:ea typeface="Calibri" pitchFamily="34" charset="-122"/>
+                <a:cs typeface="Calibri" pitchFamily="34" charset="-120"/>
+              </a:rPr>
+              <a:t>— https://public.tableau.com/app/profile/brianrodrigues./viz/TT14-CallMeMaybe/Dashboard</a:t>
             </a:r>
             <a:endParaRPr lang="en-US" sz="1100" dirty="0"/>
           </a:p>
@@ -9469,4 +9877,319 @@
     </a:ext>
   </a:extLst>
 </a:theme>
+</file>
+
+<file path=ppt/theme/theme2.xml><?xml version="1.0" encoding="utf-8"?>
+<a:theme xmlns:a="http://schemas.openxmlformats.org/drawingml/2006/main" name="Tema do Office">
+  <a:themeElements>
+    <a:clrScheme name="Office">
+      <a:dk1>
+        <a:sysClr val="windowText" lastClr="000000"/>
+      </a:dk1>
+      <a:lt1>
+        <a:sysClr val="window" lastClr="FFFFFF"/>
+      </a:lt1>
+      <a:dk2>
+        <a:srgbClr val="0E2841"/>
+      </a:dk2>
+      <a:lt2>
+        <a:srgbClr val="E8E8E8"/>
+      </a:lt2>
+      <a:accent1>
+        <a:srgbClr val="156082"/>
+      </a:accent1>
+      <a:accent2>
+        <a:srgbClr val="E97132"/>
+      </a:accent2>
+      <a:accent3>
+        <a:srgbClr val="196B24"/>
+      </a:accent3>
+      <a:accent4>
+        <a:srgbClr val="0F9ED5"/>
+      </a:accent4>
+      <a:accent5>
+        <a:srgbClr val="A02B93"/>
+      </a:accent5>
+      <a:accent6>
+        <a:srgbClr val="4EA72E"/>
+      </a:accent6>
+      <a:hlink>
+        <a:srgbClr val="467886"/>
+      </a:hlink>
+      <a:folHlink>
+        <a:srgbClr val="96607D"/>
+      </a:folHlink>
+    </a:clrScheme>
+    <a:fontScheme name="Office">
+      <a:majorFont>
+        <a:latin typeface="Aptos Display" panose="02110004020202020204"/>
+        <a:ea typeface=""/>
+        <a:cs typeface=""/>
+        <a:font script="Jpan" typeface="游ゴシック Light"/>
+        <a:font script="Hang" typeface="맑은 고딕"/>
+        <a:font script="Hans" typeface="等线 Light"/>
+        <a:font script="Hant" typeface="新細明體"/>
+        <a:font script="Arab" typeface="Times New Roman"/>
+        <a:font script="Hebr" typeface="Times New Roman"/>
+        <a:font script="Thai" typeface="Angsana New"/>
+        <a:font script="Ethi" typeface="Nyala"/>
+        <a:font script="Beng" typeface="Vrinda"/>
+        <a:font script="Gujr" typeface="Shruti"/>
+        <a:font script="Khmr" typeface="MoolBoran"/>
+        <a:font script="Knda" typeface="Tunga"/>
+        <a:font script="Guru" typeface="Raavi"/>
+        <a:font script="Cans" typeface="Euphemia"/>
+        <a:font script="Cher" typeface="Plantagenet Cherokee"/>
+        <a:font script="Yiii" typeface="Microsoft Yi Baiti"/>
+        <a:font script="Tibt" typeface="Microsoft Himalaya"/>
+        <a:font script="Thaa" typeface="MV Boli"/>
+        <a:font script="Deva" typeface="Mangal"/>
+        <a:font script="Telu" typeface="Gautami"/>
+        <a:font script="Taml" typeface="Latha"/>
+        <a:font script="Syrc" typeface="Estrangelo Edessa"/>
+        <a:font script="Orya" typeface="Kalinga"/>
+        <a:font script="Mlym" typeface="Kartika"/>
+        <a:font script="Laoo" typeface="DokChampa"/>
+        <a:font script="Sinh" typeface="Iskoola Pota"/>
+        <a:font script="Mong" typeface="Mongolian Baiti"/>
+        <a:font script="Viet" typeface="Times New Roman"/>
+        <a:font script="Uigh" typeface="Microsoft Uighur"/>
+        <a:font script="Geor" typeface="Sylfaen"/>
+        <a:font script="Armn" typeface="Arial"/>
+        <a:font script="Bugi" typeface="Leelawadee UI"/>
+        <a:font script="Bopo" typeface="Microsoft JhengHei"/>
+        <a:font script="Java" typeface="Javanese Text"/>
+        <a:font script="Lisu" typeface="Segoe UI"/>
+        <a:font script="Mymr" typeface="Myanmar Text"/>
+        <a:font script="Nkoo" typeface="Ebrima"/>
+        <a:font script="Olck" typeface="Nirmala UI"/>
+        <a:font script="Osma" typeface="Ebrima"/>
+        <a:font script="Phag" typeface="Phagspa"/>
+        <a:font script="Syrn" typeface="Estrangelo Edessa"/>
+        <a:font script="Syrj" typeface="Estrangelo Edessa"/>
+        <a:font script="Syre" typeface="Estrangelo Edessa"/>
+        <a:font script="Sora" typeface="Nirmala UI"/>
+        <a:font script="Tale" typeface="Microsoft Tai Le"/>
+        <a:font script="Talu" typeface="Microsoft New Tai Lue"/>
+        <a:font script="Tfng" typeface="Ebrima"/>
+      </a:majorFont>
+      <a:minorFont>
+        <a:latin typeface="Aptos" panose="02110004020202020204"/>
+        <a:ea typeface=""/>
+        <a:cs typeface=""/>
+        <a:font script="Jpan" typeface="游ゴシック"/>
+        <a:font script="Hang" typeface="맑은 고딕"/>
+        <a:font script="Hans" typeface="等线"/>
+        <a:font script="Hant" typeface="新細明體"/>
+        <a:font script="Arab" typeface="Arial"/>
+        <a:font script="Hebr" typeface="Arial"/>
+        <a:font script="Thai" typeface="Cordia New"/>
+        <a:font script="Ethi" typeface="Nyala"/>
+        <a:font script="Beng" typeface="Vrinda"/>
+        <a:font script="Gujr" typeface="Shruti"/>
+        <a:font script="Khmr" typeface="DaunPenh"/>
+        <a:font script="Knda" typeface="Tunga"/>
+        <a:font script="Guru" typeface="Raavi"/>
+        <a:font script="Cans" typeface="Euphemia"/>
+        <a:font script="Cher" typeface="Plantagenet Cherokee"/>
+        <a:font script="Yiii" typeface="Microsoft Yi Baiti"/>
+        <a:font script="Tibt" typeface="Microsoft Himalaya"/>
+        <a:font script="Thaa" typeface="MV Boli"/>
+        <a:font script="Deva" typeface="Mangal"/>
+        <a:font script="Telu" typeface="Gautami"/>
+        <a:font script="Taml" typeface="Latha"/>
+        <a:font script="Syrc" typeface="Estrangelo Edessa"/>
+        <a:font script="Orya" typeface="Kalinga"/>
+        <a:font script="Mlym" typeface="Kartika"/>
+        <a:font script="Laoo" typeface="DokChampa"/>
+        <a:font script="Sinh" typeface="Iskoola Pota"/>
+        <a:font script="Mong" typeface="Mongolian Baiti"/>
+        <a:font script="Viet" typeface="Arial"/>
+        <a:font script="Uigh" typeface="Microsoft Uighur"/>
+        <a:font script="Geor" typeface="Sylfaen"/>
+        <a:font script="Armn" typeface="Arial"/>
+        <a:font script="Bugi" typeface="Leelawadee UI"/>
+        <a:font script="Bopo" typeface="Microsoft JhengHei"/>
+        <a:font script="Java" typeface="Javanese Text"/>
+        <a:font script="Lisu" typeface="Segoe UI"/>
+        <a:font script="Mymr" typeface="Myanmar Text"/>
+        <a:font script="Nkoo" typeface="Ebrima"/>
+        <a:font script="Olck" typeface="Nirmala UI"/>
+        <a:font script="Osma" typeface="Ebrima"/>
+        <a:font script="Phag" typeface="Phagspa"/>
+        <a:font script="Syrn" typeface="Estrangelo Edessa"/>
+        <a:font script="Syrj" typeface="Estrangelo Edessa"/>
+        <a:font script="Syre" typeface="Estrangelo Edessa"/>
+        <a:font script="Sora" typeface="Nirmala UI"/>
+        <a:font script="Tale" typeface="Microsoft Tai Le"/>
+        <a:font script="Talu" typeface="Microsoft New Tai Lue"/>
+        <a:font script="Tfng" typeface="Ebrima"/>
+      </a:minorFont>
+    </a:fontScheme>
+    <a:fmtScheme name="Office">
+      <a:fillStyleLst>
+        <a:solidFill>
+          <a:schemeClr val="phClr"/>
+        </a:solidFill>
+        <a:gradFill rotWithShape="1">
+          <a:gsLst>
+            <a:gs pos="0">
+              <a:schemeClr val="phClr">
+                <a:lumMod val="110000"/>
+                <a:satMod val="105000"/>
+                <a:tint val="67000"/>
+              </a:schemeClr>
+            </a:gs>
+            <a:gs pos="50000">
+              <a:schemeClr val="phClr">
+                <a:lumMod val="105000"/>
+                <a:satMod val="103000"/>
+                <a:tint val="73000"/>
+              </a:schemeClr>
+            </a:gs>
+            <a:gs pos="100000">
+              <a:schemeClr val="phClr">
+                <a:lumMod val="105000"/>
+                <a:satMod val="109000"/>
+                <a:tint val="81000"/>
+              </a:schemeClr>
+            </a:gs>
+          </a:gsLst>
+          <a:lin ang="5400000" scaled="0"/>
+        </a:gradFill>
+        <a:gradFill rotWithShape="1">
+          <a:gsLst>
+            <a:gs pos="0">
+              <a:schemeClr val="phClr">
+                <a:satMod val="103000"/>
+                <a:lumMod val="102000"/>
+                <a:tint val="94000"/>
+              </a:schemeClr>
+            </a:gs>
+            <a:gs pos="50000">
+              <a:schemeClr val="phClr">
+                <a:satMod val="110000"/>
+                <a:lumMod val="100000"/>
+                <a:shade val="100000"/>
+              </a:schemeClr>
+            </a:gs>
+            <a:gs pos="100000">
+              <a:schemeClr val="phClr">
+                <a:lumMod val="99000"/>
+                <a:satMod val="120000"/>
+                <a:shade val="78000"/>
+              </a:schemeClr>
+            </a:gs>
+          </a:gsLst>
+          <a:lin ang="5400000" scaled="0"/>
+        </a:gradFill>
+      </a:fillStyleLst>
+      <a:lnStyleLst>
+        <a:ln w="12700" cap="flat" cmpd="sng" algn="ctr">
+          <a:solidFill>
+            <a:schemeClr val="phClr"/>
+          </a:solidFill>
+          <a:prstDash val="solid"/>
+          <a:miter lim="800000"/>
+        </a:ln>
+        <a:ln w="19050" cap="flat" cmpd="sng" algn="ctr">
+          <a:solidFill>
+            <a:schemeClr val="phClr"/>
+          </a:solidFill>
+          <a:prstDash val="solid"/>
+          <a:miter lim="800000"/>
+        </a:ln>
+        <a:ln w="25400" cap="flat" cmpd="sng" algn="ctr">
+          <a:solidFill>
+            <a:schemeClr val="phClr"/>
+          </a:solidFill>
+          <a:prstDash val="solid"/>
+          <a:miter lim="800000"/>
+        </a:ln>
+      </a:lnStyleLst>
+      <a:effectStyleLst>
+        <a:effectStyle>
+          <a:effectLst/>
+        </a:effectStyle>
+        <a:effectStyle>
+          <a:effectLst/>
+        </a:effectStyle>
+        <a:effectStyle>
+          <a:effectLst>
+            <a:outerShdw blurRad="57150" dist="19050" dir="5400000" algn="ctr" rotWithShape="0">
+              <a:srgbClr val="000000">
+                <a:alpha val="63000"/>
+              </a:srgbClr>
+            </a:outerShdw>
+          </a:effectLst>
+        </a:effectStyle>
+      </a:effectStyleLst>
+      <a:bgFillStyleLst>
+        <a:solidFill>
+          <a:schemeClr val="phClr"/>
+        </a:solidFill>
+        <a:solidFill>
+          <a:schemeClr val="phClr">
+            <a:tint val="95000"/>
+            <a:satMod val="170000"/>
+          </a:schemeClr>
+        </a:solidFill>
+        <a:gradFill rotWithShape="1">
+          <a:gsLst>
+            <a:gs pos="0">
+              <a:schemeClr val="phClr">
+                <a:tint val="93000"/>
+                <a:satMod val="150000"/>
+                <a:shade val="98000"/>
+                <a:lumMod val="102000"/>
+              </a:schemeClr>
+            </a:gs>
+            <a:gs pos="50000">
+              <a:schemeClr val="phClr">
+                <a:tint val="98000"/>
+                <a:satMod val="130000"/>
+                <a:shade val="90000"/>
+                <a:lumMod val="103000"/>
+              </a:schemeClr>
+            </a:gs>
+            <a:gs pos="100000">
+              <a:schemeClr val="phClr">
+                <a:shade val="63000"/>
+                <a:satMod val="120000"/>
+              </a:schemeClr>
+            </a:gs>
+          </a:gsLst>
+          <a:lin ang="5400000" scaled="0"/>
+        </a:gradFill>
+      </a:bgFillStyleLst>
+    </a:fmtScheme>
+  </a:themeElements>
+  <a:objectDefaults>
+    <a:lnDef>
+      <a:spPr/>
+      <a:bodyPr/>
+      <a:lstStyle/>
+      <a:style>
+        <a:lnRef idx="2">
+          <a:schemeClr val="accent1"/>
+        </a:lnRef>
+        <a:fillRef idx="0">
+          <a:schemeClr val="accent1"/>
+        </a:fillRef>
+        <a:effectRef idx="1">
+          <a:schemeClr val="accent1"/>
+        </a:effectRef>
+        <a:fontRef idx="minor">
+          <a:schemeClr val="tx1"/>
+        </a:fontRef>
+      </a:style>
+    </a:lnDef>
+  </a:objectDefaults>
+  <a:extraClrSchemeLst/>
+  <a:extLst>
+    <a:ext uri="{05A4C25C-085E-4340-85A3-A5531E510DB2}">
+      <thm15:themeFamily xmlns:thm15="http://schemas.microsoft.com/office/thememl/2012/main" name="Office Theme" id="{2E142A2C-CD16-42D6-873A-C26D2A0506FA}" vid="{1BDDFF52-6CD6-40A5-AB3C-68EB2F1E4D0A}"/>
+    </a:ext>
+  </a:extLst>
+</a:theme>
 </file>
</xml_diff>